<commit_message>
Met à jour la présentation pour le modèle révisé (version B)
Co-Authored-By: Claude Opus 5.5 <noreply@anthropic.com>
</commit_message>
<xml_diff>
--- a/Presentation_Validation1_HealthRetailers.pptx
+++ b/Presentation_Validation1_HealthRetailers.pptx
@@ -142,7 +142,7 @@
                 </a:solidFill>
                 <a:latin typeface="Calibri"/>
               </a:rPr>
-              <a:t>CA HT mensuel (octobre 2024 – avril 2025)</a:t>
+              <a:t>CA HT mensuel — réel (oct. 2024 – avr. 2025) puis synthétique (mai 2025 – sept. 2026)</a:t>
             </a:r>
           </a:p>
         </c:rich>
@@ -174,6 +174,142 @@
               <a:srgbClr val="1E3A8A"/>
             </a:solidFill>
           </c:spPr>
+          <c:dPt>
+            <c:idx val="7"/>
+            <c:spPr>
+              <a:solidFill>
+                <a:srgbClr val="A5B4FC"/>
+              </a:solidFill>
+            </c:spPr>
+          </c:dPt>
+          <c:dPt>
+            <c:idx val="8"/>
+            <c:spPr>
+              <a:solidFill>
+                <a:srgbClr val="A5B4FC"/>
+              </a:solidFill>
+            </c:spPr>
+          </c:dPt>
+          <c:dPt>
+            <c:idx val="9"/>
+            <c:spPr>
+              <a:solidFill>
+                <a:srgbClr val="A5B4FC"/>
+              </a:solidFill>
+            </c:spPr>
+          </c:dPt>
+          <c:dPt>
+            <c:idx val="10"/>
+            <c:spPr>
+              <a:solidFill>
+                <a:srgbClr val="A5B4FC"/>
+              </a:solidFill>
+            </c:spPr>
+          </c:dPt>
+          <c:dPt>
+            <c:idx val="11"/>
+            <c:spPr>
+              <a:solidFill>
+                <a:srgbClr val="A5B4FC"/>
+              </a:solidFill>
+            </c:spPr>
+          </c:dPt>
+          <c:dPt>
+            <c:idx val="12"/>
+            <c:spPr>
+              <a:solidFill>
+                <a:srgbClr val="A5B4FC"/>
+              </a:solidFill>
+            </c:spPr>
+          </c:dPt>
+          <c:dPt>
+            <c:idx val="13"/>
+            <c:spPr>
+              <a:solidFill>
+                <a:srgbClr val="A5B4FC"/>
+              </a:solidFill>
+            </c:spPr>
+          </c:dPt>
+          <c:dPt>
+            <c:idx val="14"/>
+            <c:spPr>
+              <a:solidFill>
+                <a:srgbClr val="A5B4FC"/>
+              </a:solidFill>
+            </c:spPr>
+          </c:dPt>
+          <c:dPt>
+            <c:idx val="15"/>
+            <c:spPr>
+              <a:solidFill>
+                <a:srgbClr val="A5B4FC"/>
+              </a:solidFill>
+            </c:spPr>
+          </c:dPt>
+          <c:dPt>
+            <c:idx val="16"/>
+            <c:spPr>
+              <a:solidFill>
+                <a:srgbClr val="A5B4FC"/>
+              </a:solidFill>
+            </c:spPr>
+          </c:dPt>
+          <c:dPt>
+            <c:idx val="17"/>
+            <c:spPr>
+              <a:solidFill>
+                <a:srgbClr val="A5B4FC"/>
+              </a:solidFill>
+            </c:spPr>
+          </c:dPt>
+          <c:dPt>
+            <c:idx val="18"/>
+            <c:spPr>
+              <a:solidFill>
+                <a:srgbClr val="A5B4FC"/>
+              </a:solidFill>
+            </c:spPr>
+          </c:dPt>
+          <c:dPt>
+            <c:idx val="19"/>
+            <c:spPr>
+              <a:solidFill>
+                <a:srgbClr val="A5B4FC"/>
+              </a:solidFill>
+            </c:spPr>
+          </c:dPt>
+          <c:dPt>
+            <c:idx val="20"/>
+            <c:spPr>
+              <a:solidFill>
+                <a:srgbClr val="A5B4FC"/>
+              </a:solidFill>
+            </c:spPr>
+          </c:dPt>
+          <c:dPt>
+            <c:idx val="21"/>
+            <c:spPr>
+              <a:solidFill>
+                <a:srgbClr val="A5B4FC"/>
+              </a:solidFill>
+            </c:spPr>
+          </c:dPt>
+          <c:dPt>
+            <c:idx val="22"/>
+            <c:spPr>
+              <a:solidFill>
+                <a:srgbClr val="A5B4FC"/>
+              </a:solidFill>
+            </c:spPr>
+          </c:dPt>
+          <c:dPt>
+            <c:idx val="23"/>
+            <c:spPr>
+              <a:solidFill>
+                <a:srgbClr val="A5B4FC"/>
+              </a:solidFill>
+            </c:spPr>
+          </c:dPt>
           <c:dLbls>
             <c:dLbl>
               <c:idx val="1"/>
@@ -239,9 +375,9 @@
           </c:dLbls>
           <c:cat>
             <c:strRef>
-              <c:f>Sheet1!$A$2:$A$8</c:f>
+              <c:f>Sheet1!$A$2:$A$25</c:f>
               <c:strCache>
-                <c:ptCount val="7"/>
+                <c:ptCount val="24"/>
                 <c:pt idx="0">
                   <c:v>oct. 24</c:v>
                 </c:pt>
@@ -263,15 +399,66 @@
                 <c:pt idx="6">
                   <c:v>avr. 25</c:v>
                 </c:pt>
+                <c:pt idx="7">
+                  <c:v>mai 25</c:v>
+                </c:pt>
+                <c:pt idx="8">
+                  <c:v>juin 25</c:v>
+                </c:pt>
+                <c:pt idx="9">
+                  <c:v>juil. 25</c:v>
+                </c:pt>
+                <c:pt idx="10">
+                  <c:v>août 25</c:v>
+                </c:pt>
+                <c:pt idx="11">
+                  <c:v>sept. 25</c:v>
+                </c:pt>
+                <c:pt idx="12">
+                  <c:v>oct. 25</c:v>
+                </c:pt>
+                <c:pt idx="13">
+                  <c:v>nov. 25</c:v>
+                </c:pt>
+                <c:pt idx="14">
+                  <c:v>déc. 25</c:v>
+                </c:pt>
+                <c:pt idx="15">
+                  <c:v>janv. 26</c:v>
+                </c:pt>
+                <c:pt idx="16">
+                  <c:v>févr. 26</c:v>
+                </c:pt>
+                <c:pt idx="17">
+                  <c:v>mars 26</c:v>
+                </c:pt>
+                <c:pt idx="18">
+                  <c:v>avr. 26</c:v>
+                </c:pt>
+                <c:pt idx="19">
+                  <c:v>mai 26</c:v>
+                </c:pt>
+                <c:pt idx="20">
+                  <c:v>juin 26</c:v>
+                </c:pt>
+                <c:pt idx="21">
+                  <c:v>juil. 26</c:v>
+                </c:pt>
+                <c:pt idx="22">
+                  <c:v>août 26</c:v>
+                </c:pt>
+                <c:pt idx="23">
+                  <c:v>sept. 26</c:v>
+                </c:pt>
               </c:strCache>
             </c:strRef>
           </c:cat>
           <c:val>
             <c:numRef>
-              <c:f>Sheet1!$B$2:$B$8</c:f>
+              <c:f>Sheet1!$B$2:$B$25</c:f>
               <c:numCache>
                 <c:formatCode>General</c:formatCode>
-                <c:ptCount val="7"/>
+                <c:ptCount val="24"/>
                 <c:pt idx="0">
                   <c:v>150417</c:v>
                 </c:pt>
@@ -292,6 +479,57 @@
                 </c:pt>
                 <c:pt idx="6">
                   <c:v>163752</c:v>
+                </c:pt>
+                <c:pt idx="7">
+                  <c:v>142015</c:v>
+                </c:pt>
+                <c:pt idx="8">
+                  <c:v>165525</c:v>
+                </c:pt>
+                <c:pt idx="9">
+                  <c:v>188170</c:v>
+                </c:pt>
+                <c:pt idx="10">
+                  <c:v>153467</c:v>
+                </c:pt>
+                <c:pt idx="11">
+                  <c:v>157576</c:v>
+                </c:pt>
+                <c:pt idx="12">
+                  <c:v>148886</c:v>
+                </c:pt>
+                <c:pt idx="13">
+                  <c:v>149159</c:v>
+                </c:pt>
+                <c:pt idx="14">
+                  <c:v>136150</c:v>
+                </c:pt>
+                <c:pt idx="15">
+                  <c:v>168117</c:v>
+                </c:pt>
+                <c:pt idx="16">
+                  <c:v>146876</c:v>
+                </c:pt>
+                <c:pt idx="17">
+                  <c:v>169207</c:v>
+                </c:pt>
+                <c:pt idx="18">
+                  <c:v>191807</c:v>
+                </c:pt>
+                <c:pt idx="19">
+                  <c:v>150049</c:v>
+                </c:pt>
+                <c:pt idx="20">
+                  <c:v>197799</c:v>
+                </c:pt>
+                <c:pt idx="21">
+                  <c:v>213178</c:v>
+                </c:pt>
+                <c:pt idx="22">
+                  <c:v>148946</c:v>
+                </c:pt>
+                <c:pt idx="23">
+                  <c:v>185207</c:v>
                 </c:pt>
               </c:numCache>
             </c:numRef>
@@ -1001,7 +1239,7 @@
           <a:lstStyle/>
           <a:p>
             <a:r>
-              <a:t>Démarche commune : préparation d'un jeu de données dédié (variables X_ séparées de la cible Y_), modèle de référence simple, puis modèles plus avancés, évaluation adaptée au type de problème. Premier signal encourageant : les ventes de compléments alimentaires sont corrélées à la température (-0,51) et à la grippe (+0,33), sur seulement 29 semaines.</a:t>
+              <a:t>Démarche commune : préparation d'un jeu de données dédié (variables X_ séparées de la cible Y_), modèle de référence simple, puis modèles plus avancés, évaluation adaptée au type de problème. Premier signal, mesuré sur la seule période réelle comme l'exige le cahier : les ventes de compléments alimentaires sont corrélées à la température et à la grippe. À confirmer par la comparaison du modèle avec et sans ces variables.</a:t>
             </a:r>
           </a:p>
         </p:txBody>
@@ -1071,7 +1309,7 @@
           <a:lstStyle/>
           <a:p>
             <a:r>
-              <a:t>Six tables de faits partagent huit dimensions conformes (constellation). En haut les dimensions temps, document, utilisateur et paiement ; en bas produit, client, fournisseur et géographie. Chaque trait relie une clé étrangère (N) à la clé primaire d'une dimension (1). Toutes les clés étrangères ont été vérifiées : 100 % retrouvent leur dimension.</a:t>
+              <a:t>Trois tables de faits (ventes, stock actuel, paiements) partagent quatre dimensions conformes (temps, produit, client, paiement) : une constellation réduite au strict besoin du cahier. Chaque trait relie une clé étrangère (N) à la clé primaire d'une dimension (1). Toutes les clés étrangères ont été vérifiées : 100 % retrouvent leur dimension.</a:t>
             </a:r>
           </a:p>
         </p:txBody>
@@ -1141,7 +1379,7 @@
           <a:lstStyle/>
           <a:p>
             <a:r>
-              <a:t>La table de faits des ventes et ses six dimensions. Le grain est une ligne de produit vendue dans un document à une date. Les mesures sont additives et signées. Les clés étrangères pointent chacune vers la clé primaire d'une dimension (relation N vers 1).</a:t>
+              <a:t>La table de faits des ventes et ses trois dimensions. Le grain est une ligne de produit vendue dans un document à une date. Les mesures sont additives et signées. Les clés étrangères pointent chacune vers la clé primaire d'une dimension (relation N vers 1).</a:t>
             </a:r>
           </a:p>
         </p:txBody>
@@ -1211,7 +1449,7 @@
           <a:lstStyle/>
           <a:p>
             <a:r>
-              <a:t>La table centrale est fait_ventes, au grain d'une ligne de produit vendue dans un document à une date (granularité recommandée par le cahier). Les mesures sont signées : les retours et avoirs viennent en négatif, ce qui permet de simplement additionner.</a:t>
+              <a:t>La table centrale est fait_ventes, au grain d'une ligne de produit vendue dans un document à une date (granularité recommandée par le cahier). Les mesures sont signées : les retours et avoirs viennent en négatif, ce qui permet de simplement additionner. Les indicateurs dérivés (marge, rupture, stock faible, montant encaissé) sont des mesures Power BI, pas des colonnes.</a:t>
             </a:r>
           </a:p>
         </p:txBody>
@@ -1281,7 +1519,7 @@
           <a:lstStyle/>
           <a:p>
             <a:r>
-              <a:t>Chaque dimension a une clé primaire simple. La dimension Temps est enrichie avec les données externes : jours fériés, vacances scolaires, météo et indicateurs épidémiques. Des membres -1 « non renseigné » garantissent que chaque clé étrangère retrouve toujours sa dimension.</a:t>
+              <a:t>Chaque dimension a une clé primaire simple et seulement les attributs exigés par le cahier. Le calendrier français est calculé ; la météo et les épidémies restent hors du Data Warehouse (jeu ML de prévision). Des membres -1 « non renseigné » garantissent que chaque clé étrangère retrouve sa dimension.</a:t>
             </a:r>
           </a:p>
         </p:txBody>
@@ -1631,7 +1869,7 @@
           <a:lstStyle/>
           <a:p>
             <a:r>
-              <a:t>Contexte : transformation digitale du secteur santé &amp; bien-être. Le drugstore enregistre chaque jour ses ventes, achats, stocks et paiements dans un logiciel de gestion. Nous disposons d'un export de 29 fichiers CSV (~370 256 enregistrements) couvrant 7 mois. Ces données ne sont aujourd'hui pas exploitées pour piloter l'activité.</a:t>
+              <a:t>Contexte : transformation digitale du secteur santé &amp; bien-être. Le drugstore enregistre chaque jour ses ventes, achats, stocks et paiements dans un logiciel de gestion. Nous disposons d'un export de 29 fichiers CSV (~370 256 enregistrements) couvrant 7 mois, que nous avons prolongé à 2 ans par des données synthétiques documentées. Ces données ne sont aujourd'hui pas exploitées pour piloter l'activité.</a:t>
             </a:r>
           </a:p>
         </p:txBody>
@@ -1701,7 +1939,7 @@
           <a:lstStyle/>
           <a:p>
             <a:r>
-              <a:t>Premier regard sur l'activité, calculé à partir de notre Data Warehouse. Le CA mensuel est assez stable avec un creux en mars. La vente comptoir domine et la grande majorité des transactions concernent un client anonyme : cela limite l'analyse client, ce qui a guidé nos choix d'objectifs.</a:t>
+              <a:t>Premier regard sur l'activité, calculé à partir de notre Data Warehouse. En bleu foncé les 7 mois réels, en clair la prolongation synthétique. Le CA mensuel réel est assez stable avec un creux en mars. La vente comptoir domine et la grande majorité des transactions concernent un client anonyme : cela limite l'analyse client, ce qui a guidé nos choix d'objectifs.</a:t>
             </a:r>
           </a:p>
         </p:txBody>
@@ -5292,7 +5530,7 @@
                 </a:solidFill>
                 <a:latin typeface="Calibri"/>
               </a:rPr>
-              <a:t>Première validation du projet</a:t>
+              <a:t>Première validation du projet — modèle révisé (version B)</a:t>
             </a:r>
           </a:p>
         </p:txBody>
@@ -7485,7 +7723,7 @@
                           </a:solidFill>
                           <a:latin typeface="Calibri"/>
                         </a:rPr>
-                        <a:t>CA et quantités par produit, marque, famille, période</a:t>
+                        <a:t>CA, quantités et marge HT par produit, marque, famille, période</a:t>
                       </a:r>
                     </a:p>
                   </a:txBody>
@@ -7531,7 +7769,7 @@
                           </a:solidFill>
                           <a:latin typeface="Calibri"/>
                         </a:rPr>
-                        <a:t>Ruptures, stock faible, rotation, classe ABC, mouvements</a:t>
+                        <a:t>Stock disponible, produits en rupture, produits en stock faible</a:t>
                       </a:r>
                     </a:p>
                   </a:txBody>
@@ -7601,7 +7839,7 @@
                           </a:solidFill>
                           <a:latin typeface="Calibri"/>
                         </a:rPr>
-                        <a:t>Paiements &amp; caisse</a:t>
+                        <a:t>Paiements</a:t>
                       </a:r>
                     </a:p>
                   </a:txBody>
@@ -7623,7 +7861,7 @@
                           </a:solidFill>
                           <a:latin typeface="Calibri"/>
                         </a:rPr>
-                        <a:t>Montants par moyen, évolution, écarts de caisse</a:t>
+                        <a:t>Montant encaissé, nombre de paiements, par moyen et période</a:t>
                       </a:r>
                     </a:p>
                   </a:txBody>
@@ -7732,7 +7970,7 @@
                 </a:solidFill>
                 <a:latin typeface="Calibri"/>
               </a:rPr>
-              <a:t>CA = Σ (Quantité × Prix HT net)</a:t>
+              <a:t>CA HT = SUM(CA_HT) · Marge HT = CA HT − Coût HT</a:t>
             </a:r>
           </a:p>
           <a:p>
@@ -7780,7 +8018,7 @@
                 </a:solidFill>
                 <a:latin typeface="Calibri"/>
               </a:rPr>
-              <a:t>Taux de rupture = Produits en rupture / Produits suivis × 100</a:t>
+              <a:t>Rupture : Quantity = 0 · stock faible : 0 &lt; Quantity ≤ seuil</a:t>
             </a:r>
           </a:p>
           <a:p>
@@ -8229,7 +8467,7 @@
                 </a:solidFill>
                 <a:latin typeface="Calibri"/>
               </a:rPr>
-              <a:t>217 semaines × famille</a:t>
+              <a:t>735 semaines × famille</a:t>
             </a:r>
           </a:p>
           <a:p>
@@ -8261,7 +8499,7 @@
                 </a:solidFill>
                 <a:latin typeface="Calibri"/>
               </a:rPr>
-              <a:t>X : historique (lags), prix, remise, canal, fériés, vacances, météo, épidémies</a:t>
+              <a:t>X : historique (lags), prix, remise, canal, fériés, météo, épidémies</a:t>
             </a:r>
           </a:p>
           <a:p>
@@ -8542,7 +8780,7 @@
                 </a:solidFill>
                 <a:latin typeface="Calibri"/>
               </a:rPr>
-              <a:t>25 700 lignes de vente</a:t>
+              <a:t>91 952 lignes de vente</a:t>
             </a:r>
           </a:p>
           <a:p>
@@ -8855,7 +9093,7 @@
                 </a:solidFill>
                 <a:latin typeface="Calibri"/>
               </a:rPr>
-              <a:t>9 707 opérations · 437 écarts</a:t>
+              <a:t>38 153 opérations · 2 107 écarts</a:t>
             </a:r>
           </a:p>
           <a:p>
@@ -8887,7 +9125,7 @@
                 </a:solidFill>
                 <a:latin typeface="Calibri"/>
               </a:rPr>
-              <a:t>X : montant, utilisateur, heure, taux d'annulation ; Y : annulation (102 cas)</a:t>
+              <a:t>X : montant, utilisateur, heure, taux d'annulation ; Y : annulation (405 cas)</a:t>
             </a:r>
           </a:p>
           <a:p>
@@ -9168,7 +9406,7 @@
                 </a:solidFill>
                 <a:latin typeface="Calibri"/>
               </a:rPr>
-              <a:t>79 clients identifiés (49 % du CA)</a:t>
+              <a:t>79 clients identifiés (42 % du CA)</a:t>
             </a:r>
           </a:p>
           <a:p>
@@ -9347,7 +9585,7 @@
                 </a:solidFill>
                 <a:latin typeface="Calibri"/>
               </a:rPr>
-              <a:t>Premier signal : sur 29 semaines, les ventes de compléments alimentaires sont corrélées à la température (−0,51) et à l'incidence de la grippe (+0,33).</a:t>
+              <a:t>Premier signal (période réelle, 30 semaines) : ventes de compléments alimentaires corrélées à la température (-0,54) et à la grippe (+0,34) — candidates, à valider.</a:t>
             </a:r>
           </a:p>
         </p:txBody>
@@ -9584,8 +9822,8 @@
         </p:blipFill>
         <p:spPr>
           <a:xfrm>
-            <a:off x="2194560" y="1143000"/>
-            <a:ext cx="7743777" cy="5230368"/>
+            <a:off x="2331720" y="1280160"/>
+            <a:ext cx="8936049" cy="5029200"/>
           </a:xfrm>
           <a:prstGeom prst="rect">
             <a:avLst/>
@@ -9626,7 +9864,7 @@
                 </a:solidFill>
                 <a:latin typeface="Calibri"/>
               </a:rPr>
-              <a:t>6</a:t>
+              <a:t>3</a:t>
             </a:r>
           </a:p>
           <a:p>
@@ -9658,7 +9896,7 @@
                 </a:solidFill>
                 <a:latin typeface="Calibri"/>
               </a:rPr>
-              <a:t>8</a:t>
+              <a:t>4</a:t>
             </a:r>
           </a:p>
           <a:p>
@@ -9936,7 +10174,7 @@
         <p:spPr>
           <a:xfrm>
             <a:off x="4343400" y="1325880"/>
-            <a:ext cx="3520440" cy="4334256"/>
+            <a:ext cx="3520440" cy="3236976"/>
           </a:xfrm>
           <a:prstGeom prst="rect">
             <a:avLst/>
@@ -10320,7 +10558,7 @@
                 </a:solidFill>
                 <a:latin typeface="Calibri"/>
               </a:rPr>
-              <a:t>Document_Id</a:t>
+              <a:t>Company_Id</a:t>
             </a:r>
           </a:p>
         </p:txBody>
@@ -10394,11 +10632,11 @@
             <a:r>
               <a:rPr sz="1200" b="1">
                 <a:solidFill>
-                  <a:srgbClr val="1D4ED8"/>
-                </a:solidFill>
-                <a:latin typeface="Calibri"/>
-              </a:rPr>
-              <a:t>Company_Id</a:t>
+                  <a:srgbClr val="0F172A"/>
+                </a:solidFill>
+                <a:latin typeface="Calibri"/>
+              </a:rPr>
+              <a:t>Document_Id</a:t>
             </a:r>
           </a:p>
         </p:txBody>
@@ -10433,11 +10671,11 @@
             <a:r>
               <a:rPr sz="1000" b="1">
                 <a:solidFill>
-                  <a:srgbClr val="1D4ED8"/>
-                </a:solidFill>
-                <a:latin typeface="Calibri"/>
-              </a:rPr>
-              <a:t>FK</a:t>
+                  <a:srgbClr val="0F172A"/>
+                </a:solidFill>
+                <a:latin typeface="Calibri"/>
+              </a:rPr>
+              <a:t>dégénérée</a:t>
             </a:r>
           </a:p>
         </p:txBody>
@@ -10470,13 +10708,13 @@
               </a:spcAft>
             </a:pPr>
             <a:r>
-              <a:rPr sz="1200" b="1">
-                <a:solidFill>
-                  <a:srgbClr val="1D4ED8"/>
-                </a:solidFill>
-                <a:latin typeface="Calibri"/>
-              </a:rPr>
-              <a:t>CreatedBy</a:t>
+              <a:rPr sz="1200" b="0">
+                <a:solidFill>
+                  <a:srgbClr val="0F172A"/>
+                </a:solidFill>
+                <a:latin typeface="Calibri"/>
+              </a:rPr>
+              <a:t>QuantiteVendue</a:t>
             </a:r>
           </a:p>
         </p:txBody>
@@ -10511,11 +10749,11 @@
             <a:r>
               <a:rPr sz="1000" b="1">
                 <a:solidFill>
-                  <a:srgbClr val="1D4ED8"/>
-                </a:solidFill>
-                <a:latin typeface="Calibri"/>
-              </a:rPr>
-              <a:t>FK</a:t>
+                  <a:srgbClr val="059669"/>
+                </a:solidFill>
+                <a:latin typeface="Calibri"/>
+              </a:rPr>
+              <a:t>mesure</a:t>
             </a:r>
           </a:p>
         </p:txBody>
@@ -10548,13 +10786,13 @@
               </a:spcAft>
             </a:pPr>
             <a:r>
-              <a:rPr sz="1200" b="1">
-                <a:solidFill>
-                  <a:srgbClr val="1D4ED8"/>
-                </a:solidFill>
-                <a:latin typeface="Calibri"/>
-              </a:rPr>
-              <a:t>PaymentMode_Id</a:t>
+              <a:rPr sz="1200" b="0">
+                <a:solidFill>
+                  <a:srgbClr val="0F172A"/>
+                </a:solidFill>
+                <a:latin typeface="Calibri"/>
+              </a:rPr>
+              <a:t>Remise_HT</a:t>
             </a:r>
           </a:p>
         </p:txBody>
@@ -10589,11 +10827,11 @@
             <a:r>
               <a:rPr sz="1000" b="1">
                 <a:solidFill>
-                  <a:srgbClr val="1D4ED8"/>
-                </a:solidFill>
-                <a:latin typeface="Calibri"/>
-              </a:rPr>
-              <a:t>FK</a:t>
+                  <a:srgbClr val="059669"/>
+                </a:solidFill>
+                <a:latin typeface="Calibri"/>
+              </a:rPr>
+              <a:t>mesure</a:t>
             </a:r>
           </a:p>
         </p:txBody>
@@ -10632,7 +10870,7 @@
                 </a:solidFill>
                 <a:latin typeface="Calibri"/>
               </a:rPr>
-              <a:t>QuantiteVendue</a:t>
+              <a:t>CA_HT</a:t>
             </a:r>
           </a:p>
         </p:txBody>
@@ -10710,7 +10948,7 @@
                 </a:solidFill>
                 <a:latin typeface="Calibri"/>
               </a:rPr>
-              <a:t>CA_HT</a:t>
+              <a:t>Cout_HT</a:t>
             </a:r>
           </a:p>
         </p:txBody>
@@ -10782,13 +11020,13 @@
               </a:spcAft>
             </a:pPr>
             <a:r>
-              <a:rPr sz="1200" b="0">
-                <a:solidFill>
-                  <a:srgbClr val="0F172A"/>
-                </a:solidFill>
-                <a:latin typeface="Calibri"/>
-              </a:rPr>
-              <a:t>CA_TTC</a:t>
+              <a:rPr sz="1200" b="1">
+                <a:solidFill>
+                  <a:srgbClr val="475569"/>
+                </a:solidFill>
+                <a:latin typeface="Calibri"/>
+              </a:rPr>
+              <a:t>Marge HT = CA HT − Cout HT</a:t>
             </a:r>
           </a:p>
         </p:txBody>
@@ -10823,291 +11061,18 @@
             <a:r>
               <a:rPr sz="1000" b="1">
                 <a:solidFill>
-                  <a:srgbClr val="059669"/>
-                </a:solidFill>
-                <a:latin typeface="Calibri"/>
-              </a:rPr>
-              <a:t>mesure</a:t>
-            </a:r>
-          </a:p>
-        </p:txBody>
-      </p:sp>
-      <p:sp>
-        <p:nvSpPr>
-          <p:cNvPr id="30" name="TextBox 29"/>
-          <p:cNvSpPr txBox="1"/>
-          <p:nvPr/>
-        </p:nvSpPr>
-        <p:spPr>
-          <a:xfrm>
-            <a:off x="4434840" y="4498848"/>
-            <a:ext cx="2514600" cy="274320"/>
-          </a:xfrm>
-          <a:prstGeom prst="rect">
-            <a:avLst/>
-          </a:prstGeom>
-          <a:noFill/>
-        </p:spPr>
-        <p:txBody>
-          <a:bodyPr wrap="square" anchor="t" lIns="45720" rIns="45720">
-            <a:spAutoFit/>
-          </a:bodyPr>
-          <a:lstStyle/>
-          <a:p>
-            <a:pPr algn="l">
-              <a:spcAft>
-                <a:spcPts val="600"/>
-              </a:spcAft>
-            </a:pPr>
-            <a:r>
-              <a:rPr sz="1200" b="0">
-                <a:solidFill>
-                  <a:srgbClr val="0F172A"/>
-                </a:solidFill>
-                <a:latin typeface="Calibri"/>
-              </a:rPr>
-              <a:t>Remise_HT</a:t>
-            </a:r>
-          </a:p>
-        </p:txBody>
-      </p:sp>
-      <p:sp>
-        <p:nvSpPr>
-          <p:cNvPr id="31" name="TextBox 30"/>
-          <p:cNvSpPr txBox="1"/>
-          <p:nvPr/>
-        </p:nvSpPr>
-        <p:spPr>
-          <a:xfrm>
-            <a:off x="6812279" y="4498848"/>
-            <a:ext cx="960120" cy="274320"/>
-          </a:xfrm>
-          <a:prstGeom prst="rect">
-            <a:avLst/>
-          </a:prstGeom>
-          <a:noFill/>
-        </p:spPr>
-        <p:txBody>
-          <a:bodyPr wrap="square" anchor="t" lIns="45720" rIns="45720">
-            <a:spAutoFit/>
-          </a:bodyPr>
-          <a:lstStyle/>
-          <a:p>
-            <a:pPr algn="r">
-              <a:spcAft>
-                <a:spcPts val="600"/>
-              </a:spcAft>
-            </a:pPr>
-            <a:r>
-              <a:rPr sz="1000" b="1">
-                <a:solidFill>
-                  <a:srgbClr val="059669"/>
-                </a:solidFill>
-                <a:latin typeface="Calibri"/>
-              </a:rPr>
-              <a:t>mesure</a:t>
-            </a:r>
-          </a:p>
-        </p:txBody>
-      </p:sp>
-      <p:sp>
-        <p:nvSpPr>
-          <p:cNvPr id="32" name="TextBox 31"/>
-          <p:cNvSpPr txBox="1"/>
-          <p:nvPr/>
-        </p:nvSpPr>
-        <p:spPr>
-          <a:xfrm>
-            <a:off x="4434840" y="4773168"/>
-            <a:ext cx="2514600" cy="274320"/>
-          </a:xfrm>
-          <a:prstGeom prst="rect">
-            <a:avLst/>
-          </a:prstGeom>
-          <a:noFill/>
-        </p:spPr>
-        <p:txBody>
-          <a:bodyPr wrap="square" anchor="t" lIns="45720" rIns="45720">
-            <a:spAutoFit/>
-          </a:bodyPr>
-          <a:lstStyle/>
-          <a:p>
-            <a:pPr algn="l">
-              <a:spcAft>
-                <a:spcPts val="600"/>
-              </a:spcAft>
-            </a:pPr>
-            <a:r>
-              <a:rPr sz="1200" b="0">
-                <a:solidFill>
-                  <a:srgbClr val="0F172A"/>
-                </a:solidFill>
-                <a:latin typeface="Calibri"/>
-              </a:rPr>
-              <a:t>Cout_HT</a:t>
-            </a:r>
-          </a:p>
-        </p:txBody>
-      </p:sp>
-      <p:sp>
-        <p:nvSpPr>
-          <p:cNvPr id="33" name="TextBox 32"/>
-          <p:cNvSpPr txBox="1"/>
-          <p:nvPr/>
-        </p:nvSpPr>
-        <p:spPr>
-          <a:xfrm>
-            <a:off x="6812279" y="4773168"/>
-            <a:ext cx="960120" cy="274320"/>
-          </a:xfrm>
-          <a:prstGeom prst="rect">
-            <a:avLst/>
-          </a:prstGeom>
-          <a:noFill/>
-        </p:spPr>
-        <p:txBody>
-          <a:bodyPr wrap="square" anchor="t" lIns="45720" rIns="45720">
-            <a:spAutoFit/>
-          </a:bodyPr>
-          <a:lstStyle/>
-          <a:p>
-            <a:pPr algn="r">
-              <a:spcAft>
-                <a:spcPts val="600"/>
-              </a:spcAft>
-            </a:pPr>
-            <a:r>
-              <a:rPr sz="1000" b="1">
-                <a:solidFill>
-                  <a:srgbClr val="059669"/>
-                </a:solidFill>
-                <a:latin typeface="Calibri"/>
-              </a:rPr>
-              <a:t>mesure</a:t>
-            </a:r>
-          </a:p>
-        </p:txBody>
-      </p:sp>
-      <p:sp>
-        <p:nvSpPr>
-          <p:cNvPr id="34" name="TextBox 33"/>
-          <p:cNvSpPr txBox="1"/>
-          <p:nvPr/>
-        </p:nvSpPr>
-        <p:spPr>
-          <a:xfrm>
-            <a:off x="4434840" y="5047488"/>
-            <a:ext cx="2514600" cy="274320"/>
-          </a:xfrm>
-          <a:prstGeom prst="rect">
-            <a:avLst/>
-          </a:prstGeom>
-          <a:noFill/>
-        </p:spPr>
-        <p:txBody>
-          <a:bodyPr wrap="square" anchor="t" lIns="45720" rIns="45720">
-            <a:spAutoFit/>
-          </a:bodyPr>
-          <a:lstStyle/>
-          <a:p>
-            <a:pPr algn="l">
-              <a:spcAft>
-                <a:spcPts val="600"/>
-              </a:spcAft>
-            </a:pPr>
-            <a:r>
-              <a:rPr sz="1200" b="0">
-                <a:solidFill>
-                  <a:srgbClr val="0F172A"/>
-                </a:solidFill>
-                <a:latin typeface="Calibri"/>
-              </a:rPr>
-              <a:t>Marge_HT</a:t>
-            </a:r>
-          </a:p>
-        </p:txBody>
-      </p:sp>
-      <p:sp>
-        <p:nvSpPr>
-          <p:cNvPr id="35" name="TextBox 34"/>
-          <p:cNvSpPr txBox="1"/>
-          <p:nvPr/>
-        </p:nvSpPr>
-        <p:spPr>
-          <a:xfrm>
-            <a:off x="6812279" y="5047488"/>
-            <a:ext cx="960120" cy="274320"/>
-          </a:xfrm>
-          <a:prstGeom prst="rect">
-            <a:avLst/>
-          </a:prstGeom>
-          <a:noFill/>
-        </p:spPr>
-        <p:txBody>
-          <a:bodyPr wrap="square" anchor="t" lIns="45720" rIns="45720">
-            <a:spAutoFit/>
-          </a:bodyPr>
-          <a:lstStyle/>
-          <a:p>
-            <a:pPr algn="r">
-              <a:spcAft>
-                <a:spcPts val="600"/>
-              </a:spcAft>
-            </a:pPr>
-            <a:r>
-              <a:rPr sz="1000" b="1">
-                <a:solidFill>
-                  <a:srgbClr val="059669"/>
-                </a:solidFill>
-                <a:latin typeface="Calibri"/>
-              </a:rPr>
-              <a:t>mesure</a:t>
-            </a:r>
-          </a:p>
-        </p:txBody>
-      </p:sp>
-      <p:sp>
-        <p:nvSpPr>
-          <p:cNvPr id="36" name="TextBox 35"/>
-          <p:cNvSpPr txBox="1"/>
-          <p:nvPr/>
-        </p:nvSpPr>
-        <p:spPr>
-          <a:xfrm>
-            <a:off x="4434840" y="5321808"/>
-            <a:ext cx="2514600" cy="274320"/>
-          </a:xfrm>
-          <a:prstGeom prst="rect">
-            <a:avLst/>
-          </a:prstGeom>
-          <a:noFill/>
-        </p:spPr>
-        <p:txBody>
-          <a:bodyPr wrap="square" anchor="t" lIns="45720" rIns="45720">
-            <a:spAutoFit/>
-          </a:bodyPr>
-          <a:lstStyle/>
-          <a:p>
-            <a:pPr algn="l">
-              <a:spcAft>
-                <a:spcPts val="600"/>
-              </a:spcAft>
-            </a:pPr>
-            <a:r>
-              <a:rPr sz="1200" b="0">
-                <a:solidFill>
-                  <a:srgbClr val="0F172A"/>
-                </a:solidFill>
-                <a:latin typeface="Calibri"/>
-              </a:rPr>
-              <a:t>… + 17 colonnes descriptives</a:t>
-            </a:r>
-          </a:p>
-        </p:txBody>
-      </p:sp>
-      <p:sp>
-        <p:nvSpPr>
-          <p:cNvPr id="37" name="Rectangle 36"/>
+                  <a:srgbClr val="475569"/>
+                </a:solidFill>
+                <a:latin typeface="Calibri"/>
+              </a:rPr>
+              <a:t>Power BI</a:t>
+            </a:r>
+          </a:p>
+        </p:txBody>
+      </p:sp>
+      <p:sp>
+        <p:nvSpPr>
+          <p:cNvPr id="30" name="Rectangle 29"/>
           <p:cNvSpPr/>
           <p:nvPr/>
         </p:nvSpPr>
@@ -11151,7 +11116,7 @@
       </p:sp>
       <p:sp>
         <p:nvSpPr>
-          <p:cNvPr id="38" name="Rectangle 37"/>
+          <p:cNvPr id="31" name="Rectangle 30"/>
           <p:cNvSpPr/>
           <p:nvPr/>
         </p:nvSpPr>
@@ -11193,7 +11158,7 @@
       </p:sp>
       <p:sp>
         <p:nvSpPr>
-          <p:cNvPr id="39" name="TextBox 38"/>
+          <p:cNvPr id="32" name="TextBox 31"/>
           <p:cNvSpPr txBox="1"/>
           <p:nvPr/>
         </p:nvSpPr>
@@ -11232,7 +11197,7 @@
       </p:sp>
       <p:sp>
         <p:nvSpPr>
-          <p:cNvPr id="40" name="TextBox 39"/>
+          <p:cNvPr id="33" name="TextBox 32"/>
           <p:cNvSpPr txBox="1"/>
           <p:nvPr/>
         </p:nvSpPr>
@@ -11271,7 +11236,7 @@
       </p:sp>
       <p:sp>
         <p:nvSpPr>
-          <p:cNvPr id="41" name="TextBox 40"/>
+          <p:cNvPr id="34" name="TextBox 33"/>
           <p:cNvSpPr txBox="1"/>
           <p:nvPr/>
         </p:nvSpPr>
@@ -11310,7 +11275,7 @@
       </p:sp>
       <p:sp>
         <p:nvSpPr>
-          <p:cNvPr id="42" name="TextBox 41"/>
+          <p:cNvPr id="35" name="TextBox 34"/>
           <p:cNvSpPr txBox="1"/>
           <p:nvPr/>
         </p:nvSpPr>
@@ -11342,14 +11307,14 @@
                 </a:solidFill>
                 <a:latin typeface="Calibri"/>
               </a:rPr>
-              <a:t>Date, mois, saison</a:t>
-            </a:r>
-          </a:p>
-        </p:txBody>
-      </p:sp>
-      <p:sp>
-        <p:nvSpPr>
-          <p:cNvPr id="43" name="TextBox 42"/>
+              <a:t>Date, année, trimestre</a:t>
+            </a:r>
+          </a:p>
+        </p:txBody>
+      </p:sp>
+      <p:sp>
+        <p:nvSpPr>
+          <p:cNvPr id="36" name="TextBox 35"/>
           <p:cNvSpPr txBox="1"/>
           <p:nvPr/>
         </p:nvSpPr>
@@ -11381,14 +11346,14 @@
                 </a:solidFill>
                 <a:latin typeface="Calibri"/>
               </a:rPr>
-              <a:t>Férié, vacances</a:t>
-            </a:r>
-          </a:p>
-        </p:txBody>
-      </p:sp>
-      <p:sp>
-        <p:nvSpPr>
-          <p:cNvPr id="44" name="TextBox 43"/>
+              <a:t>Mois, semaine ISO</a:t>
+            </a:r>
+          </a:p>
+        </p:txBody>
+      </p:sp>
+      <p:sp>
+        <p:nvSpPr>
+          <p:cNvPr id="37" name="TextBox 36"/>
           <p:cNvSpPr txBox="1"/>
           <p:nvPr/>
         </p:nvSpPr>
@@ -11420,14 +11385,14 @@
                 </a:solidFill>
                 <a:latin typeface="Calibri"/>
               </a:rPr>
-              <a:t>Météo, épidémies</a:t>
+              <a:t>Jour férié</a:t>
             </a:r>
           </a:p>
         </p:txBody>
       </p:sp>
       <p:cxnSp>
         <p:nvCxnSpPr>
-          <p:cNvPr id="45" name="Connector 44"/>
+          <p:cNvPr id="38" name="Connector 37"/>
           <p:cNvCxnSpPr/>
           <p:nvPr/>
         </p:nvCxnSpPr>
@@ -11462,7 +11427,7 @@
       </p:cxnSp>
       <p:sp>
         <p:nvSpPr>
-          <p:cNvPr id="46" name="TextBox 45"/>
+          <p:cNvPr id="39" name="TextBox 38"/>
           <p:cNvSpPr txBox="1"/>
           <p:nvPr/>
         </p:nvSpPr>
@@ -11501,7 +11466,7 @@
       </p:sp>
       <p:sp>
         <p:nvSpPr>
-          <p:cNvPr id="47" name="TextBox 46"/>
+          <p:cNvPr id="40" name="TextBox 39"/>
           <p:cNvSpPr txBox="1"/>
           <p:nvPr/>
         </p:nvSpPr>
@@ -11540,14 +11505,14 @@
       </p:sp>
       <p:sp>
         <p:nvSpPr>
-          <p:cNvPr id="48" name="Rectangle 47"/>
+          <p:cNvPr id="41" name="Rectangle 40"/>
           <p:cNvSpPr/>
           <p:nvPr/>
         </p:nvSpPr>
         <p:spPr>
           <a:xfrm>
-            <a:off x="502920" y="3191255"/>
-            <a:ext cx="3017520" cy="1316736"/>
+            <a:off x="8686800" y="1325880"/>
+            <a:ext cx="3017520" cy="1591055"/>
           </a:xfrm>
           <a:prstGeom prst="rect">
             <a:avLst/>
@@ -11584,13 +11549,13 @@
       </p:sp>
       <p:sp>
         <p:nvSpPr>
-          <p:cNvPr id="49" name="Rectangle 48"/>
+          <p:cNvPr id="42" name="Rectangle 41"/>
           <p:cNvSpPr/>
           <p:nvPr/>
         </p:nvSpPr>
         <p:spPr>
           <a:xfrm>
-            <a:off x="502920" y="3191255"/>
+            <a:off x="8686800" y="1325880"/>
             <a:ext cx="3017520" cy="384048"/>
           </a:xfrm>
           <a:prstGeom prst="rect">
@@ -11626,13 +11591,13 @@
       </p:sp>
       <p:sp>
         <p:nvSpPr>
-          <p:cNvPr id="50" name="TextBox 49"/>
+          <p:cNvPr id="43" name="TextBox 42"/>
           <p:cNvSpPr txBox="1"/>
           <p:nvPr/>
         </p:nvSpPr>
         <p:spPr>
           <a:xfrm>
-            <a:off x="594360" y="3218687"/>
+            <a:off x="8778240" y="1353312"/>
             <a:ext cx="2834639" cy="329184"/>
           </a:xfrm>
           <a:prstGeom prst="rect">
@@ -11658,20 +11623,20 @@
                 </a:solidFill>
                 <a:latin typeface="Calibri"/>
               </a:rPr>
-              <a:t>dim_document</a:t>
-            </a:r>
-          </a:p>
-        </p:txBody>
-      </p:sp>
-      <p:sp>
-        <p:nvSpPr>
-          <p:cNvPr id="51" name="TextBox 50"/>
+              <a:t>dim_produit</a:t>
+            </a:r>
+          </a:p>
+        </p:txBody>
+      </p:sp>
+      <p:sp>
+        <p:nvSpPr>
+          <p:cNvPr id="44" name="TextBox 43"/>
           <p:cNvSpPr txBox="1"/>
           <p:nvPr/>
         </p:nvSpPr>
         <p:spPr>
           <a:xfrm>
-            <a:off x="594360" y="3621023"/>
+            <a:off x="8778240" y="1755648"/>
             <a:ext cx="2011679" cy="274320"/>
           </a:xfrm>
           <a:prstGeom prst="rect">
@@ -11697,20 +11662,20 @@
                 </a:solidFill>
                 <a:latin typeface="Calibri"/>
               </a:rPr>
-              <a:t>Document_Id</a:t>
-            </a:r>
-          </a:p>
-        </p:txBody>
-      </p:sp>
-      <p:sp>
-        <p:nvSpPr>
-          <p:cNvPr id="52" name="TextBox 51"/>
+              <a:t>Product_Id</a:t>
+            </a:r>
+          </a:p>
+        </p:txBody>
+      </p:sp>
+      <p:sp>
+        <p:nvSpPr>
+          <p:cNvPr id="45" name="TextBox 44"/>
           <p:cNvSpPr txBox="1"/>
           <p:nvPr/>
         </p:nvSpPr>
         <p:spPr>
           <a:xfrm>
-            <a:off x="2468879" y="3621023"/>
+            <a:off x="10652760" y="1755648"/>
             <a:ext cx="960120" cy="274320"/>
           </a:xfrm>
           <a:prstGeom prst="rect">
@@ -11743,13 +11708,13 @@
       </p:sp>
       <p:sp>
         <p:nvSpPr>
-          <p:cNvPr id="53" name="TextBox 52"/>
+          <p:cNvPr id="46" name="TextBox 45"/>
           <p:cNvSpPr txBox="1"/>
           <p:nvPr/>
         </p:nvSpPr>
         <p:spPr>
           <a:xfrm>
-            <a:off x="594360" y="3895343"/>
+            <a:off x="8778240" y="2029967"/>
             <a:ext cx="2011679" cy="274320"/>
           </a:xfrm>
           <a:prstGeom prst="rect">
@@ -11775,20 +11740,20 @@
                 </a:solidFill>
                 <a:latin typeface="Calibri"/>
               </a:rPr>
-              <a:t>Numéro, type</a:t>
-            </a:r>
-          </a:p>
-        </p:txBody>
-      </p:sp>
-      <p:sp>
-        <p:nvSpPr>
-          <p:cNvPr id="54" name="TextBox 53"/>
+              <a:t>Libellé, famille</a:t>
+            </a:r>
+          </a:p>
+        </p:txBody>
+      </p:sp>
+      <p:sp>
+        <p:nvSpPr>
+          <p:cNvPr id="47" name="TextBox 46"/>
           <p:cNvSpPr txBox="1"/>
           <p:nvPr/>
         </p:nvSpPr>
         <p:spPr>
           <a:xfrm>
-            <a:off x="594360" y="4169663"/>
+            <a:off x="8778240" y="2304288"/>
             <a:ext cx="2011679" cy="274320"/>
           </a:xfrm>
           <a:prstGeom prst="rect">
@@ -11814,21 +11779,60 @@
                 </a:solidFill>
                 <a:latin typeface="Calibri"/>
               </a:rPr>
-              <a:t>Statut, canal</a:t>
+              <a:t>Marque</a:t>
+            </a:r>
+          </a:p>
+        </p:txBody>
+      </p:sp>
+      <p:sp>
+        <p:nvSpPr>
+          <p:cNvPr id="48" name="TextBox 47"/>
+          <p:cNvSpPr txBox="1"/>
+          <p:nvPr/>
+        </p:nvSpPr>
+        <p:spPr>
+          <a:xfrm>
+            <a:off x="8778240" y="2578608"/>
+            <a:ext cx="2011679" cy="274320"/>
+          </a:xfrm>
+          <a:prstGeom prst="rect">
+            <a:avLst/>
+          </a:prstGeom>
+          <a:noFill/>
+        </p:spPr>
+        <p:txBody>
+          <a:bodyPr wrap="square" anchor="t" lIns="45720" rIns="45720">
+            <a:spAutoFit/>
+          </a:bodyPr>
+          <a:lstStyle/>
+          <a:p>
+            <a:pPr algn="l">
+              <a:spcAft>
+                <a:spcPts val="600"/>
+              </a:spcAft>
+            </a:pPr>
+            <a:r>
+              <a:rPr sz="1200" b="0">
+                <a:solidFill>
+                  <a:srgbClr val="0F172A"/>
+                </a:solidFill>
+                <a:latin typeface="Calibri"/>
+              </a:rPr>
+              <a:t>Seuil d'alerte</a:t>
             </a:r>
           </a:p>
         </p:txBody>
       </p:sp>
       <p:cxnSp>
         <p:nvCxnSpPr>
-          <p:cNvPr id="55" name="Connector 54"/>
+          <p:cNvPr id="49" name="Connector 48"/>
           <p:cNvCxnSpPr/>
           <p:nvPr/>
         </p:nvCxnSpPr>
         <p:spPr>
           <a:xfrm flipV="1">
-            <a:off x="3520439" y="2715768"/>
-            <a:ext cx="822961" cy="1042415"/>
+            <a:off x="7863840" y="1892807"/>
+            <a:ext cx="822960" cy="548641"/>
           </a:xfrm>
           <a:prstGeom prst="line">
             <a:avLst/>
@@ -11856,13 +11860,13 @@
       </p:cxnSp>
       <p:sp>
         <p:nvSpPr>
-          <p:cNvPr id="56" name="TextBox 55"/>
+          <p:cNvPr id="50" name="TextBox 49"/>
           <p:cNvSpPr txBox="1"/>
           <p:nvPr/>
         </p:nvSpPr>
         <p:spPr>
           <a:xfrm>
-            <a:off x="3547872" y="3483863"/>
+            <a:off x="8412480" y="1618487"/>
             <a:ext cx="274320" cy="274320"/>
           </a:xfrm>
           <a:prstGeom prst="rect">
@@ -11895,13 +11899,13 @@
       </p:sp>
       <p:sp>
         <p:nvSpPr>
-          <p:cNvPr id="57" name="TextBox 56"/>
+          <p:cNvPr id="51" name="TextBox 50"/>
           <p:cNvSpPr txBox="1"/>
           <p:nvPr/>
         </p:nvSpPr>
         <p:spPr>
           <a:xfrm>
-            <a:off x="4069080" y="2441448"/>
+            <a:off x="7891271" y="2167128"/>
             <a:ext cx="274320" cy="274320"/>
           </a:xfrm>
           <a:prstGeom prst="rect">
@@ -11934,14 +11938,14 @@
       </p:sp>
       <p:sp>
         <p:nvSpPr>
-          <p:cNvPr id="58" name="Rectangle 57"/>
+          <p:cNvPr id="52" name="Rectangle 51"/>
           <p:cNvSpPr/>
           <p:nvPr/>
         </p:nvSpPr>
         <p:spPr>
           <a:xfrm>
-            <a:off x="502920" y="4782312"/>
-            <a:ext cx="3017520" cy="1042416"/>
+            <a:off x="8686800" y="3191255"/>
+            <a:ext cx="3017520" cy="1316736"/>
           </a:xfrm>
           <a:prstGeom prst="rect">
             <a:avLst/>
@@ -11978,13 +11982,13 @@
       </p:sp>
       <p:sp>
         <p:nvSpPr>
-          <p:cNvPr id="59" name="Rectangle 58"/>
+          <p:cNvPr id="53" name="Rectangle 52"/>
           <p:cNvSpPr/>
           <p:nvPr/>
         </p:nvSpPr>
         <p:spPr>
           <a:xfrm>
-            <a:off x="502920" y="4782312"/>
+            <a:off x="8686800" y="3191255"/>
             <a:ext cx="3017520" cy="384048"/>
           </a:xfrm>
           <a:prstGeom prst="rect">
@@ -12020,13 +12024,13 @@
       </p:sp>
       <p:sp>
         <p:nvSpPr>
-          <p:cNvPr id="60" name="TextBox 59"/>
+          <p:cNvPr id="54" name="TextBox 53"/>
           <p:cNvSpPr txBox="1"/>
           <p:nvPr/>
         </p:nvSpPr>
         <p:spPr>
           <a:xfrm>
-            <a:off x="594360" y="4809744"/>
+            <a:off x="8778240" y="3218687"/>
             <a:ext cx="2834639" cy="329184"/>
           </a:xfrm>
           <a:prstGeom prst="rect">
@@ -12052,20 +12056,20 @@
                 </a:solidFill>
                 <a:latin typeface="Calibri"/>
               </a:rPr>
-              <a:t>dim_utilisateur</a:t>
-            </a:r>
-          </a:p>
-        </p:txBody>
-      </p:sp>
-      <p:sp>
-        <p:nvSpPr>
-          <p:cNvPr id="61" name="TextBox 60"/>
+              <a:t>dim_client</a:t>
+            </a:r>
+          </a:p>
+        </p:txBody>
+      </p:sp>
+      <p:sp>
+        <p:nvSpPr>
+          <p:cNvPr id="55" name="TextBox 54"/>
           <p:cNvSpPr txBox="1"/>
           <p:nvPr/>
         </p:nvSpPr>
         <p:spPr>
           <a:xfrm>
-            <a:off x="594360" y="5212079"/>
+            <a:off x="8778240" y="3621023"/>
             <a:ext cx="2011679" cy="274320"/>
           </a:xfrm>
           <a:prstGeom prst="rect">
@@ -12091,20 +12095,20 @@
                 </a:solidFill>
                 <a:latin typeface="Calibri"/>
               </a:rPr>
-              <a:t>User_Id</a:t>
-            </a:r>
-          </a:p>
-        </p:txBody>
-      </p:sp>
-      <p:sp>
-        <p:nvSpPr>
-          <p:cNvPr id="62" name="TextBox 61"/>
+              <a:t>Company_Id</a:t>
+            </a:r>
+          </a:p>
+        </p:txBody>
+      </p:sp>
+      <p:sp>
+        <p:nvSpPr>
+          <p:cNvPr id="56" name="TextBox 55"/>
           <p:cNvSpPr txBox="1"/>
           <p:nvPr/>
         </p:nvSpPr>
         <p:spPr>
           <a:xfrm>
-            <a:off x="2468879" y="5212079"/>
+            <a:off x="10652760" y="3621023"/>
             <a:ext cx="960120" cy="274320"/>
           </a:xfrm>
           <a:prstGeom prst="rect">
@@ -12137,13 +12141,13 @@
       </p:sp>
       <p:sp>
         <p:nvSpPr>
-          <p:cNvPr id="63" name="TextBox 62"/>
+          <p:cNvPr id="57" name="TextBox 56"/>
           <p:cNvSpPr txBox="1"/>
           <p:nvPr/>
         </p:nvSpPr>
         <p:spPr>
           <a:xfrm>
-            <a:off x="594360" y="5486399"/>
+            <a:off x="8778240" y="3895343"/>
             <a:ext cx="2011679" cy="274320"/>
           </a:xfrm>
           <a:prstGeom prst="rect">
@@ -12169,21 +12173,60 @@
                 </a:solidFill>
                 <a:latin typeface="Calibri"/>
               </a:rPr>
-              <a:t>Nom du vendeur</a:t>
+              <a:t>Nom, type de client</a:t>
+            </a:r>
+          </a:p>
+        </p:txBody>
+      </p:sp>
+      <p:sp>
+        <p:nvSpPr>
+          <p:cNvPr id="58" name="TextBox 57"/>
+          <p:cNvSpPr txBox="1"/>
+          <p:nvPr/>
+        </p:nvSpPr>
+        <p:spPr>
+          <a:xfrm>
+            <a:off x="8778240" y="4169663"/>
+            <a:ext cx="2011679" cy="274320"/>
+          </a:xfrm>
+          <a:prstGeom prst="rect">
+            <a:avLst/>
+          </a:prstGeom>
+          <a:noFill/>
+        </p:spPr>
+        <p:txBody>
+          <a:bodyPr wrap="square" anchor="t" lIns="45720" rIns="45720">
+            <a:spAutoFit/>
+          </a:bodyPr>
+          <a:lstStyle/>
+          <a:p>
+            <a:pPr algn="l">
+              <a:spcAft>
+                <a:spcPts val="600"/>
+              </a:spcAft>
+            </a:pPr>
+            <a:r>
+              <a:rPr sz="1200" b="0">
+                <a:solidFill>
+                  <a:srgbClr val="0F172A"/>
+                </a:solidFill>
+                <a:latin typeface="Calibri"/>
+              </a:rPr>
+              <a:t>Client identifié (oui / non)</a:t>
             </a:r>
           </a:p>
         </p:txBody>
       </p:sp>
       <p:cxnSp>
         <p:nvCxnSpPr>
-          <p:cNvPr id="64" name="Connector 63"/>
+          <p:cNvPr id="59" name="Connector 58"/>
           <p:cNvCxnSpPr/>
           <p:nvPr/>
         </p:nvCxnSpPr>
         <p:spPr>
-          <a:xfrm flipV="1">
-            <a:off x="3520439" y="3264408"/>
-            <a:ext cx="822961" cy="2084832"/>
+          <a:xfrm>
+            <a:off x="7863840" y="2715768"/>
+            <a:ext cx="822960" cy="1042415"/>
           </a:xfrm>
           <a:prstGeom prst="line">
             <a:avLst/>
@@ -12211,13 +12254,13 @@
       </p:cxnSp>
       <p:sp>
         <p:nvSpPr>
-          <p:cNvPr id="65" name="TextBox 64"/>
+          <p:cNvPr id="60" name="TextBox 59"/>
           <p:cNvSpPr txBox="1"/>
           <p:nvPr/>
         </p:nvSpPr>
         <p:spPr>
           <a:xfrm>
-            <a:off x="3547872" y="5074920"/>
+            <a:off x="8412480" y="3483863"/>
             <a:ext cx="274320" cy="274320"/>
           </a:xfrm>
           <a:prstGeom prst="rect">
@@ -12250,13 +12293,13 @@
       </p:sp>
       <p:sp>
         <p:nvSpPr>
-          <p:cNvPr id="66" name="TextBox 65"/>
+          <p:cNvPr id="61" name="TextBox 60"/>
           <p:cNvSpPr txBox="1"/>
           <p:nvPr/>
         </p:nvSpPr>
         <p:spPr>
           <a:xfrm>
-            <a:off x="4069080" y="2990088"/>
+            <a:off x="7891271" y="2441448"/>
             <a:ext cx="274320" cy="274320"/>
           </a:xfrm>
           <a:prstGeom prst="rect">
@@ -12289,1189 +12332,7 @@
       </p:sp>
       <p:sp>
         <p:nvSpPr>
-          <p:cNvPr id="67" name="Rectangle 66"/>
-          <p:cNvSpPr/>
-          <p:nvPr/>
-        </p:nvSpPr>
-        <p:spPr>
-          <a:xfrm>
-            <a:off x="8686800" y="1325880"/>
-            <a:ext cx="3017520" cy="1591055"/>
-          </a:xfrm>
-          <a:prstGeom prst="rect">
-            <a:avLst/>
-          </a:prstGeom>
-          <a:solidFill>
-            <a:srgbClr val="FFFFFF"/>
-          </a:solidFill>
-          <a:ln w="15875">
-            <a:solidFill>
-              <a:srgbClr val="334155"/>
-            </a:solidFill>
-          </a:ln>
-          <a:effectLst/>
-        </p:spPr>
-        <p:style>
-          <a:lnRef idx="1">
-            <a:schemeClr val="accent1"/>
-          </a:lnRef>
-          <a:fillRef idx="3">
-            <a:schemeClr val="accent1"/>
-          </a:fillRef>
-          <a:effectRef idx="2">
-            <a:schemeClr val="accent1"/>
-          </a:effectRef>
-          <a:fontRef idx="minor">
-            <a:schemeClr val="lt1"/>
-          </a:fontRef>
-        </p:style>
-        <p:txBody>
-          <a:bodyPr rtlCol="0" anchor="ctr"/>
-          <a:lstStyle/>
-          <a:p/>
-        </p:txBody>
-      </p:sp>
-      <p:sp>
-        <p:nvSpPr>
-          <p:cNvPr id="68" name="Rectangle 67"/>
-          <p:cNvSpPr/>
-          <p:nvPr/>
-        </p:nvSpPr>
-        <p:spPr>
-          <a:xfrm>
-            <a:off x="8686800" y="1325880"/>
-            <a:ext cx="3017520" cy="384048"/>
-          </a:xfrm>
-          <a:prstGeom prst="rect">
-            <a:avLst/>
-          </a:prstGeom>
-          <a:solidFill>
-            <a:srgbClr val="334155"/>
-          </a:solidFill>
-          <a:ln>
-            <a:noFill/>
-          </a:ln>
-          <a:effectLst/>
-        </p:spPr>
-        <p:style>
-          <a:lnRef idx="1">
-            <a:schemeClr val="accent1"/>
-          </a:lnRef>
-          <a:fillRef idx="3">
-            <a:schemeClr val="accent1"/>
-          </a:fillRef>
-          <a:effectRef idx="2">
-            <a:schemeClr val="accent1"/>
-          </a:effectRef>
-          <a:fontRef idx="minor">
-            <a:schemeClr val="lt1"/>
-          </a:fontRef>
-        </p:style>
-        <p:txBody>
-          <a:bodyPr rtlCol="0" anchor="ctr"/>
-          <a:lstStyle/>
-          <a:p/>
-        </p:txBody>
-      </p:sp>
-      <p:sp>
-        <p:nvSpPr>
-          <p:cNvPr id="69" name="TextBox 68"/>
-          <p:cNvSpPr txBox="1"/>
-          <p:nvPr/>
-        </p:nvSpPr>
-        <p:spPr>
-          <a:xfrm>
-            <a:off x="8778240" y="1353312"/>
-            <a:ext cx="2834639" cy="329184"/>
-          </a:xfrm>
-          <a:prstGeom prst="rect">
-            <a:avLst/>
-          </a:prstGeom>
-          <a:noFill/>
-        </p:spPr>
-        <p:txBody>
-          <a:bodyPr wrap="square" anchor="ctr" lIns="45720" rIns="45720">
-            <a:spAutoFit/>
-          </a:bodyPr>
-          <a:lstStyle/>
-          <a:p>
-            <a:pPr algn="l">
-              <a:spcAft>
-                <a:spcPts val="600"/>
-              </a:spcAft>
-            </a:pPr>
-            <a:r>
-              <a:rPr sz="1400" b="1">
-                <a:solidFill>
-                  <a:srgbClr val="FFFFFF"/>
-                </a:solidFill>
-                <a:latin typeface="Calibri"/>
-              </a:rPr>
-              <a:t>dim_produit</a:t>
-            </a:r>
-          </a:p>
-        </p:txBody>
-      </p:sp>
-      <p:sp>
-        <p:nvSpPr>
-          <p:cNvPr id="70" name="TextBox 69"/>
-          <p:cNvSpPr txBox="1"/>
-          <p:nvPr/>
-        </p:nvSpPr>
-        <p:spPr>
-          <a:xfrm>
-            <a:off x="8778240" y="1755648"/>
-            <a:ext cx="2011679" cy="274320"/>
-          </a:xfrm>
-          <a:prstGeom prst="rect">
-            <a:avLst/>
-          </a:prstGeom>
-          <a:noFill/>
-        </p:spPr>
-        <p:txBody>
-          <a:bodyPr wrap="square" anchor="t" lIns="45720" rIns="45720">
-            <a:spAutoFit/>
-          </a:bodyPr>
-          <a:lstStyle/>
-          <a:p>
-            <a:pPr algn="l">
-              <a:spcAft>
-                <a:spcPts val="600"/>
-              </a:spcAft>
-            </a:pPr>
-            <a:r>
-              <a:rPr sz="1200" b="1">
-                <a:solidFill>
-                  <a:srgbClr val="B91C1C"/>
-                </a:solidFill>
-                <a:latin typeface="Calibri"/>
-              </a:rPr>
-              <a:t>Product_Id</a:t>
-            </a:r>
-          </a:p>
-        </p:txBody>
-      </p:sp>
-      <p:sp>
-        <p:nvSpPr>
-          <p:cNvPr id="71" name="TextBox 70"/>
-          <p:cNvSpPr txBox="1"/>
-          <p:nvPr/>
-        </p:nvSpPr>
-        <p:spPr>
-          <a:xfrm>
-            <a:off x="10652760" y="1755648"/>
-            <a:ext cx="960120" cy="274320"/>
-          </a:xfrm>
-          <a:prstGeom prst="rect">
-            <a:avLst/>
-          </a:prstGeom>
-          <a:noFill/>
-        </p:spPr>
-        <p:txBody>
-          <a:bodyPr wrap="square" anchor="t" lIns="45720" rIns="45720">
-            <a:spAutoFit/>
-          </a:bodyPr>
-          <a:lstStyle/>
-          <a:p>
-            <a:pPr algn="r">
-              <a:spcAft>
-                <a:spcPts val="600"/>
-              </a:spcAft>
-            </a:pPr>
-            <a:r>
-              <a:rPr sz="1000" b="1">
-                <a:solidFill>
-                  <a:srgbClr val="B91C1C"/>
-                </a:solidFill>
-                <a:latin typeface="Calibri"/>
-              </a:rPr>
-              <a:t>PK</a:t>
-            </a:r>
-          </a:p>
-        </p:txBody>
-      </p:sp>
-      <p:sp>
-        <p:nvSpPr>
-          <p:cNvPr id="72" name="TextBox 71"/>
-          <p:cNvSpPr txBox="1"/>
-          <p:nvPr/>
-        </p:nvSpPr>
-        <p:spPr>
-          <a:xfrm>
-            <a:off x="8778240" y="2029967"/>
-            <a:ext cx="2011679" cy="274320"/>
-          </a:xfrm>
-          <a:prstGeom prst="rect">
-            <a:avLst/>
-          </a:prstGeom>
-          <a:noFill/>
-        </p:spPr>
-        <p:txBody>
-          <a:bodyPr wrap="square" anchor="t" lIns="45720" rIns="45720">
-            <a:spAutoFit/>
-          </a:bodyPr>
-          <a:lstStyle/>
-          <a:p>
-            <a:pPr algn="l">
-              <a:spcAft>
-                <a:spcPts val="600"/>
-              </a:spcAft>
-            </a:pPr>
-            <a:r>
-              <a:rPr sz="1200" b="0">
-                <a:solidFill>
-                  <a:srgbClr val="0F172A"/>
-                </a:solidFill>
-                <a:latin typeface="Calibri"/>
-              </a:rPr>
-              <a:t>Libellé, famille</a:t>
-            </a:r>
-          </a:p>
-        </p:txBody>
-      </p:sp>
-      <p:sp>
-        <p:nvSpPr>
-          <p:cNvPr id="73" name="TextBox 72"/>
-          <p:cNvSpPr txBox="1"/>
-          <p:nvPr/>
-        </p:nvSpPr>
-        <p:spPr>
-          <a:xfrm>
-            <a:off x="8778240" y="2304288"/>
-            <a:ext cx="2011679" cy="274320"/>
-          </a:xfrm>
-          <a:prstGeom prst="rect">
-            <a:avLst/>
-          </a:prstGeom>
-          <a:noFill/>
-        </p:spPr>
-        <p:txBody>
-          <a:bodyPr wrap="square" anchor="t" lIns="45720" rIns="45720">
-            <a:spAutoFit/>
-          </a:bodyPr>
-          <a:lstStyle/>
-          <a:p>
-            <a:pPr algn="l">
-              <a:spcAft>
-                <a:spcPts val="600"/>
-              </a:spcAft>
-            </a:pPr>
-            <a:r>
-              <a:rPr sz="1200" b="0">
-                <a:solidFill>
-                  <a:srgbClr val="0F172A"/>
-                </a:solidFill>
-                <a:latin typeface="Calibri"/>
-              </a:rPr>
-              <a:t>Marque, code-barres</a:t>
-            </a:r>
-          </a:p>
-        </p:txBody>
-      </p:sp>
-      <p:sp>
-        <p:nvSpPr>
-          <p:cNvPr id="74" name="TextBox 73"/>
-          <p:cNvSpPr txBox="1"/>
-          <p:nvPr/>
-        </p:nvSpPr>
-        <p:spPr>
-          <a:xfrm>
-            <a:off x="8778240" y="2578608"/>
-            <a:ext cx="2011679" cy="274320"/>
-          </a:xfrm>
-          <a:prstGeom prst="rect">
-            <a:avLst/>
-          </a:prstGeom>
-          <a:noFill/>
-        </p:spPr>
-        <p:txBody>
-          <a:bodyPr wrap="square" anchor="t" lIns="45720" rIns="45720">
-            <a:spAutoFit/>
-          </a:bodyPr>
-          <a:lstStyle/>
-          <a:p>
-            <a:pPr algn="l">
-              <a:spcAft>
-                <a:spcPts val="600"/>
-              </a:spcAft>
-            </a:pPr>
-            <a:r>
-              <a:rPr sz="1200" b="0">
-                <a:solidFill>
-                  <a:srgbClr val="0F172A"/>
-                </a:solidFill>
-                <a:latin typeface="Calibri"/>
-              </a:rPr>
-              <a:t>Prix, TVA</a:t>
-            </a:r>
-          </a:p>
-        </p:txBody>
-      </p:sp>
-      <p:cxnSp>
-        <p:nvCxnSpPr>
-          <p:cNvPr id="75" name="Connector 74"/>
-          <p:cNvCxnSpPr/>
-          <p:nvPr/>
-        </p:nvCxnSpPr>
-        <p:spPr>
-          <a:xfrm flipV="1">
-            <a:off x="7863840" y="1892807"/>
-            <a:ext cx="822960" cy="548641"/>
-          </a:xfrm>
-          <a:prstGeom prst="line">
-            <a:avLst/>
-          </a:prstGeom>
-          <a:ln w="19050">
-            <a:solidFill>
-              <a:srgbClr val="475569"/>
-            </a:solidFill>
-          </a:ln>
-        </p:spPr>
-        <p:style>
-          <a:lnRef idx="2">
-            <a:schemeClr val="accent1"/>
-          </a:lnRef>
-          <a:fillRef idx="0">
-            <a:schemeClr val="accent1"/>
-          </a:fillRef>
-          <a:effectRef idx="1">
-            <a:schemeClr val="accent1"/>
-          </a:effectRef>
-          <a:fontRef idx="minor">
-            <a:schemeClr val="tx1"/>
-          </a:fontRef>
-        </p:style>
-      </p:cxnSp>
-      <p:sp>
-        <p:nvSpPr>
-          <p:cNvPr id="76" name="TextBox 75"/>
-          <p:cNvSpPr txBox="1"/>
-          <p:nvPr/>
-        </p:nvSpPr>
-        <p:spPr>
-          <a:xfrm>
-            <a:off x="8412480" y="1618487"/>
-            <a:ext cx="274320" cy="274320"/>
-          </a:xfrm>
-          <a:prstGeom prst="rect">
-            <a:avLst/>
-          </a:prstGeom>
-          <a:noFill/>
-        </p:spPr>
-        <p:txBody>
-          <a:bodyPr wrap="square" anchor="t" lIns="45720" rIns="45720">
-            <a:spAutoFit/>
-          </a:bodyPr>
-          <a:lstStyle/>
-          <a:p>
-            <a:pPr algn="l">
-              <a:spcAft>
-                <a:spcPts val="600"/>
-              </a:spcAft>
-            </a:pPr>
-            <a:r>
-              <a:rPr sz="1100" b="1">
-                <a:solidFill>
-                  <a:srgbClr val="475569"/>
-                </a:solidFill>
-                <a:latin typeface="Calibri"/>
-              </a:rPr>
-              <a:t>1</a:t>
-            </a:r>
-          </a:p>
-        </p:txBody>
-      </p:sp>
-      <p:sp>
-        <p:nvSpPr>
-          <p:cNvPr id="77" name="TextBox 76"/>
-          <p:cNvSpPr txBox="1"/>
-          <p:nvPr/>
-        </p:nvSpPr>
-        <p:spPr>
-          <a:xfrm>
-            <a:off x="7891271" y="2167128"/>
-            <a:ext cx="274320" cy="274320"/>
-          </a:xfrm>
-          <a:prstGeom prst="rect">
-            <a:avLst/>
-          </a:prstGeom>
-          <a:noFill/>
-        </p:spPr>
-        <p:txBody>
-          <a:bodyPr wrap="square" anchor="t" lIns="45720" rIns="45720">
-            <a:spAutoFit/>
-          </a:bodyPr>
-          <a:lstStyle/>
-          <a:p>
-            <a:pPr algn="l">
-              <a:spcAft>
-                <a:spcPts val="600"/>
-              </a:spcAft>
-            </a:pPr>
-            <a:r>
-              <a:rPr sz="1100" b="1">
-                <a:solidFill>
-                  <a:srgbClr val="475569"/>
-                </a:solidFill>
-                <a:latin typeface="Calibri"/>
-              </a:rPr>
-              <a:t>N</a:t>
-            </a:r>
-          </a:p>
-        </p:txBody>
-      </p:sp>
-      <p:sp>
-        <p:nvSpPr>
-          <p:cNvPr id="78" name="Rectangle 77"/>
-          <p:cNvSpPr/>
-          <p:nvPr/>
-        </p:nvSpPr>
-        <p:spPr>
-          <a:xfrm>
-            <a:off x="8686800" y="3191255"/>
-            <a:ext cx="3017520" cy="1316736"/>
-          </a:xfrm>
-          <a:prstGeom prst="rect">
-            <a:avLst/>
-          </a:prstGeom>
-          <a:solidFill>
-            <a:srgbClr val="FFFFFF"/>
-          </a:solidFill>
-          <a:ln w="15875">
-            <a:solidFill>
-              <a:srgbClr val="334155"/>
-            </a:solidFill>
-          </a:ln>
-          <a:effectLst/>
-        </p:spPr>
-        <p:style>
-          <a:lnRef idx="1">
-            <a:schemeClr val="accent1"/>
-          </a:lnRef>
-          <a:fillRef idx="3">
-            <a:schemeClr val="accent1"/>
-          </a:fillRef>
-          <a:effectRef idx="2">
-            <a:schemeClr val="accent1"/>
-          </a:effectRef>
-          <a:fontRef idx="minor">
-            <a:schemeClr val="lt1"/>
-          </a:fontRef>
-        </p:style>
-        <p:txBody>
-          <a:bodyPr rtlCol="0" anchor="ctr"/>
-          <a:lstStyle/>
-          <a:p/>
-        </p:txBody>
-      </p:sp>
-      <p:sp>
-        <p:nvSpPr>
-          <p:cNvPr id="79" name="Rectangle 78"/>
-          <p:cNvSpPr/>
-          <p:nvPr/>
-        </p:nvSpPr>
-        <p:spPr>
-          <a:xfrm>
-            <a:off x="8686800" y="3191255"/>
-            <a:ext cx="3017520" cy="384048"/>
-          </a:xfrm>
-          <a:prstGeom prst="rect">
-            <a:avLst/>
-          </a:prstGeom>
-          <a:solidFill>
-            <a:srgbClr val="334155"/>
-          </a:solidFill>
-          <a:ln>
-            <a:noFill/>
-          </a:ln>
-          <a:effectLst/>
-        </p:spPr>
-        <p:style>
-          <a:lnRef idx="1">
-            <a:schemeClr val="accent1"/>
-          </a:lnRef>
-          <a:fillRef idx="3">
-            <a:schemeClr val="accent1"/>
-          </a:fillRef>
-          <a:effectRef idx="2">
-            <a:schemeClr val="accent1"/>
-          </a:effectRef>
-          <a:fontRef idx="minor">
-            <a:schemeClr val="lt1"/>
-          </a:fontRef>
-        </p:style>
-        <p:txBody>
-          <a:bodyPr rtlCol="0" anchor="ctr"/>
-          <a:lstStyle/>
-          <a:p/>
-        </p:txBody>
-      </p:sp>
-      <p:sp>
-        <p:nvSpPr>
-          <p:cNvPr id="80" name="TextBox 79"/>
-          <p:cNvSpPr txBox="1"/>
-          <p:nvPr/>
-        </p:nvSpPr>
-        <p:spPr>
-          <a:xfrm>
-            <a:off x="8778240" y="3218687"/>
-            <a:ext cx="2834639" cy="329184"/>
-          </a:xfrm>
-          <a:prstGeom prst="rect">
-            <a:avLst/>
-          </a:prstGeom>
-          <a:noFill/>
-        </p:spPr>
-        <p:txBody>
-          <a:bodyPr wrap="square" anchor="ctr" lIns="45720" rIns="45720">
-            <a:spAutoFit/>
-          </a:bodyPr>
-          <a:lstStyle/>
-          <a:p>
-            <a:pPr algn="l">
-              <a:spcAft>
-                <a:spcPts val="600"/>
-              </a:spcAft>
-            </a:pPr>
-            <a:r>
-              <a:rPr sz="1400" b="1">
-                <a:solidFill>
-                  <a:srgbClr val="FFFFFF"/>
-                </a:solidFill>
-                <a:latin typeface="Calibri"/>
-              </a:rPr>
-              <a:t>dim_client</a:t>
-            </a:r>
-          </a:p>
-        </p:txBody>
-      </p:sp>
-      <p:sp>
-        <p:nvSpPr>
-          <p:cNvPr id="81" name="TextBox 80"/>
-          <p:cNvSpPr txBox="1"/>
-          <p:nvPr/>
-        </p:nvSpPr>
-        <p:spPr>
-          <a:xfrm>
-            <a:off x="8778240" y="3621023"/>
-            <a:ext cx="2011679" cy="274320"/>
-          </a:xfrm>
-          <a:prstGeom prst="rect">
-            <a:avLst/>
-          </a:prstGeom>
-          <a:noFill/>
-        </p:spPr>
-        <p:txBody>
-          <a:bodyPr wrap="square" anchor="t" lIns="45720" rIns="45720">
-            <a:spAutoFit/>
-          </a:bodyPr>
-          <a:lstStyle/>
-          <a:p>
-            <a:pPr algn="l">
-              <a:spcAft>
-                <a:spcPts val="600"/>
-              </a:spcAft>
-            </a:pPr>
-            <a:r>
-              <a:rPr sz="1200" b="1">
-                <a:solidFill>
-                  <a:srgbClr val="B91C1C"/>
-                </a:solidFill>
-                <a:latin typeface="Calibri"/>
-              </a:rPr>
-              <a:t>Company_Id</a:t>
-            </a:r>
-          </a:p>
-        </p:txBody>
-      </p:sp>
-      <p:sp>
-        <p:nvSpPr>
-          <p:cNvPr id="82" name="TextBox 81"/>
-          <p:cNvSpPr txBox="1"/>
-          <p:nvPr/>
-        </p:nvSpPr>
-        <p:spPr>
-          <a:xfrm>
-            <a:off x="10652760" y="3621023"/>
-            <a:ext cx="960120" cy="274320"/>
-          </a:xfrm>
-          <a:prstGeom prst="rect">
-            <a:avLst/>
-          </a:prstGeom>
-          <a:noFill/>
-        </p:spPr>
-        <p:txBody>
-          <a:bodyPr wrap="square" anchor="t" lIns="45720" rIns="45720">
-            <a:spAutoFit/>
-          </a:bodyPr>
-          <a:lstStyle/>
-          <a:p>
-            <a:pPr algn="r">
-              <a:spcAft>
-                <a:spcPts val="600"/>
-              </a:spcAft>
-            </a:pPr>
-            <a:r>
-              <a:rPr sz="1000" b="1">
-                <a:solidFill>
-                  <a:srgbClr val="B91C1C"/>
-                </a:solidFill>
-                <a:latin typeface="Calibri"/>
-              </a:rPr>
-              <a:t>PK</a:t>
-            </a:r>
-          </a:p>
-        </p:txBody>
-      </p:sp>
-      <p:sp>
-        <p:nvSpPr>
-          <p:cNvPr id="83" name="TextBox 82"/>
-          <p:cNvSpPr txBox="1"/>
-          <p:nvPr/>
-        </p:nvSpPr>
-        <p:spPr>
-          <a:xfrm>
-            <a:off x="8778240" y="3895343"/>
-            <a:ext cx="2011679" cy="274320"/>
-          </a:xfrm>
-          <a:prstGeom prst="rect">
-            <a:avLst/>
-          </a:prstGeom>
-          <a:noFill/>
-        </p:spPr>
-        <p:txBody>
-          <a:bodyPr wrap="square" anchor="t" lIns="45720" rIns="45720">
-            <a:spAutoFit/>
-          </a:bodyPr>
-          <a:lstStyle/>
-          <a:p>
-            <a:pPr algn="l">
-              <a:spcAft>
-                <a:spcPts val="600"/>
-              </a:spcAft>
-            </a:pPr>
-            <a:r>
-              <a:rPr sz="1200" b="0">
-                <a:solidFill>
-                  <a:srgbClr val="0F172A"/>
-                </a:solidFill>
-                <a:latin typeface="Calibri"/>
-              </a:rPr>
-              <a:t>Nom, type de client</a:t>
-            </a:r>
-          </a:p>
-        </p:txBody>
-      </p:sp>
-      <p:sp>
-        <p:nvSpPr>
-          <p:cNvPr id="84" name="TextBox 83"/>
-          <p:cNvSpPr txBox="1"/>
-          <p:nvPr/>
-        </p:nvSpPr>
-        <p:spPr>
-          <a:xfrm>
-            <a:off x="8778240" y="4169663"/>
-            <a:ext cx="2011679" cy="274320"/>
-          </a:xfrm>
-          <a:prstGeom prst="rect">
-            <a:avLst/>
-          </a:prstGeom>
-          <a:noFill/>
-        </p:spPr>
-        <p:txBody>
-          <a:bodyPr wrap="square" anchor="t" lIns="45720" rIns="45720">
-            <a:spAutoFit/>
-          </a:bodyPr>
-          <a:lstStyle/>
-          <a:p>
-            <a:pPr algn="l">
-              <a:spcAft>
-                <a:spcPts val="600"/>
-              </a:spcAft>
-            </a:pPr>
-            <a:r>
-              <a:rPr sz="1200" b="0">
-                <a:solidFill>
-                  <a:srgbClr val="0F172A"/>
-                </a:solidFill>
-                <a:latin typeface="Calibri"/>
-              </a:rPr>
-              <a:t>Ville → dim_geographie</a:t>
-            </a:r>
-          </a:p>
-        </p:txBody>
-      </p:sp>
-      <p:cxnSp>
-        <p:nvCxnSpPr>
-          <p:cNvPr id="85" name="Connector 84"/>
-          <p:cNvCxnSpPr/>
-          <p:nvPr/>
-        </p:nvCxnSpPr>
-        <p:spPr>
-          <a:xfrm>
-            <a:off x="7863840" y="2990088"/>
-            <a:ext cx="822960" cy="768095"/>
-          </a:xfrm>
-          <a:prstGeom prst="line">
-            <a:avLst/>
-          </a:prstGeom>
-          <a:ln w="19050">
-            <a:solidFill>
-              <a:srgbClr val="475569"/>
-            </a:solidFill>
-          </a:ln>
-        </p:spPr>
-        <p:style>
-          <a:lnRef idx="2">
-            <a:schemeClr val="accent1"/>
-          </a:lnRef>
-          <a:fillRef idx="0">
-            <a:schemeClr val="accent1"/>
-          </a:fillRef>
-          <a:effectRef idx="1">
-            <a:schemeClr val="accent1"/>
-          </a:effectRef>
-          <a:fontRef idx="minor">
-            <a:schemeClr val="tx1"/>
-          </a:fontRef>
-        </p:style>
-      </p:cxnSp>
-      <p:sp>
-        <p:nvSpPr>
-          <p:cNvPr id="86" name="TextBox 85"/>
-          <p:cNvSpPr txBox="1"/>
-          <p:nvPr/>
-        </p:nvSpPr>
-        <p:spPr>
-          <a:xfrm>
-            <a:off x="8412480" y="3483863"/>
-            <a:ext cx="274320" cy="274320"/>
-          </a:xfrm>
-          <a:prstGeom prst="rect">
-            <a:avLst/>
-          </a:prstGeom>
-          <a:noFill/>
-        </p:spPr>
-        <p:txBody>
-          <a:bodyPr wrap="square" anchor="t" lIns="45720" rIns="45720">
-            <a:spAutoFit/>
-          </a:bodyPr>
-          <a:lstStyle/>
-          <a:p>
-            <a:pPr algn="l">
-              <a:spcAft>
-                <a:spcPts val="600"/>
-              </a:spcAft>
-            </a:pPr>
-            <a:r>
-              <a:rPr sz="1100" b="1">
-                <a:solidFill>
-                  <a:srgbClr val="475569"/>
-                </a:solidFill>
-                <a:latin typeface="Calibri"/>
-              </a:rPr>
-              <a:t>1</a:t>
-            </a:r>
-          </a:p>
-        </p:txBody>
-      </p:sp>
-      <p:sp>
-        <p:nvSpPr>
-          <p:cNvPr id="87" name="TextBox 86"/>
-          <p:cNvSpPr txBox="1"/>
-          <p:nvPr/>
-        </p:nvSpPr>
-        <p:spPr>
-          <a:xfrm>
-            <a:off x="7891271" y="2715768"/>
-            <a:ext cx="274320" cy="274320"/>
-          </a:xfrm>
-          <a:prstGeom prst="rect">
-            <a:avLst/>
-          </a:prstGeom>
-          <a:noFill/>
-        </p:spPr>
-        <p:txBody>
-          <a:bodyPr wrap="square" anchor="t" lIns="45720" rIns="45720">
-            <a:spAutoFit/>
-          </a:bodyPr>
-          <a:lstStyle/>
-          <a:p>
-            <a:pPr algn="l">
-              <a:spcAft>
-                <a:spcPts val="600"/>
-              </a:spcAft>
-            </a:pPr>
-            <a:r>
-              <a:rPr sz="1100" b="1">
-                <a:solidFill>
-                  <a:srgbClr val="475569"/>
-                </a:solidFill>
-                <a:latin typeface="Calibri"/>
-              </a:rPr>
-              <a:t>N</a:t>
-            </a:r>
-          </a:p>
-        </p:txBody>
-      </p:sp>
-      <p:sp>
-        <p:nvSpPr>
-          <p:cNvPr id="88" name="Rectangle 87"/>
-          <p:cNvSpPr/>
-          <p:nvPr/>
-        </p:nvSpPr>
-        <p:spPr>
-          <a:xfrm>
-            <a:off x="8686800" y="4782312"/>
-            <a:ext cx="3017520" cy="1042416"/>
-          </a:xfrm>
-          <a:prstGeom prst="rect">
-            <a:avLst/>
-          </a:prstGeom>
-          <a:solidFill>
-            <a:srgbClr val="FFFFFF"/>
-          </a:solidFill>
-          <a:ln w="15875">
-            <a:solidFill>
-              <a:srgbClr val="334155"/>
-            </a:solidFill>
-          </a:ln>
-          <a:effectLst/>
-        </p:spPr>
-        <p:style>
-          <a:lnRef idx="1">
-            <a:schemeClr val="accent1"/>
-          </a:lnRef>
-          <a:fillRef idx="3">
-            <a:schemeClr val="accent1"/>
-          </a:fillRef>
-          <a:effectRef idx="2">
-            <a:schemeClr val="accent1"/>
-          </a:effectRef>
-          <a:fontRef idx="minor">
-            <a:schemeClr val="lt1"/>
-          </a:fontRef>
-        </p:style>
-        <p:txBody>
-          <a:bodyPr rtlCol="0" anchor="ctr"/>
-          <a:lstStyle/>
-          <a:p/>
-        </p:txBody>
-      </p:sp>
-      <p:sp>
-        <p:nvSpPr>
-          <p:cNvPr id="89" name="Rectangle 88"/>
-          <p:cNvSpPr/>
-          <p:nvPr/>
-        </p:nvSpPr>
-        <p:spPr>
-          <a:xfrm>
-            <a:off x="8686800" y="4782312"/>
-            <a:ext cx="3017520" cy="384048"/>
-          </a:xfrm>
-          <a:prstGeom prst="rect">
-            <a:avLst/>
-          </a:prstGeom>
-          <a:solidFill>
-            <a:srgbClr val="334155"/>
-          </a:solidFill>
-          <a:ln>
-            <a:noFill/>
-          </a:ln>
-          <a:effectLst/>
-        </p:spPr>
-        <p:style>
-          <a:lnRef idx="1">
-            <a:schemeClr val="accent1"/>
-          </a:lnRef>
-          <a:fillRef idx="3">
-            <a:schemeClr val="accent1"/>
-          </a:fillRef>
-          <a:effectRef idx="2">
-            <a:schemeClr val="accent1"/>
-          </a:effectRef>
-          <a:fontRef idx="minor">
-            <a:schemeClr val="lt1"/>
-          </a:fontRef>
-        </p:style>
-        <p:txBody>
-          <a:bodyPr rtlCol="0" anchor="ctr"/>
-          <a:lstStyle/>
-          <a:p/>
-        </p:txBody>
-      </p:sp>
-      <p:sp>
-        <p:nvSpPr>
-          <p:cNvPr id="90" name="TextBox 89"/>
-          <p:cNvSpPr txBox="1"/>
-          <p:nvPr/>
-        </p:nvSpPr>
-        <p:spPr>
-          <a:xfrm>
-            <a:off x="8778240" y="4809744"/>
-            <a:ext cx="2834639" cy="329184"/>
-          </a:xfrm>
-          <a:prstGeom prst="rect">
-            <a:avLst/>
-          </a:prstGeom>
-          <a:noFill/>
-        </p:spPr>
-        <p:txBody>
-          <a:bodyPr wrap="square" anchor="ctr" lIns="45720" rIns="45720">
-            <a:spAutoFit/>
-          </a:bodyPr>
-          <a:lstStyle/>
-          <a:p>
-            <a:pPr algn="l">
-              <a:spcAft>
-                <a:spcPts val="600"/>
-              </a:spcAft>
-            </a:pPr>
-            <a:r>
-              <a:rPr sz="1400" b="1">
-                <a:solidFill>
-                  <a:srgbClr val="FFFFFF"/>
-                </a:solidFill>
-                <a:latin typeface="Calibri"/>
-              </a:rPr>
-              <a:t>dim_paiement</a:t>
-            </a:r>
-          </a:p>
-        </p:txBody>
-      </p:sp>
-      <p:sp>
-        <p:nvSpPr>
-          <p:cNvPr id="91" name="TextBox 90"/>
-          <p:cNvSpPr txBox="1"/>
-          <p:nvPr/>
-        </p:nvSpPr>
-        <p:spPr>
-          <a:xfrm>
-            <a:off x="8778240" y="5212079"/>
-            <a:ext cx="2011679" cy="274320"/>
-          </a:xfrm>
-          <a:prstGeom prst="rect">
-            <a:avLst/>
-          </a:prstGeom>
-          <a:noFill/>
-        </p:spPr>
-        <p:txBody>
-          <a:bodyPr wrap="square" anchor="t" lIns="45720" rIns="45720">
-            <a:spAutoFit/>
-          </a:bodyPr>
-          <a:lstStyle/>
-          <a:p>
-            <a:pPr algn="l">
-              <a:spcAft>
-                <a:spcPts val="600"/>
-              </a:spcAft>
-            </a:pPr>
-            <a:r>
-              <a:rPr sz="1200" b="1">
-                <a:solidFill>
-                  <a:srgbClr val="B91C1C"/>
-                </a:solidFill>
-                <a:latin typeface="Calibri"/>
-              </a:rPr>
-              <a:t>PaymentMode_Id</a:t>
-            </a:r>
-          </a:p>
-        </p:txBody>
-      </p:sp>
-      <p:sp>
-        <p:nvSpPr>
-          <p:cNvPr id="92" name="TextBox 91"/>
-          <p:cNvSpPr txBox="1"/>
-          <p:nvPr/>
-        </p:nvSpPr>
-        <p:spPr>
-          <a:xfrm>
-            <a:off x="10652760" y="5212079"/>
-            <a:ext cx="960120" cy="274320"/>
-          </a:xfrm>
-          <a:prstGeom prst="rect">
-            <a:avLst/>
-          </a:prstGeom>
-          <a:noFill/>
-        </p:spPr>
-        <p:txBody>
-          <a:bodyPr wrap="square" anchor="t" lIns="45720" rIns="45720">
-            <a:spAutoFit/>
-          </a:bodyPr>
-          <a:lstStyle/>
-          <a:p>
-            <a:pPr algn="r">
-              <a:spcAft>
-                <a:spcPts val="600"/>
-              </a:spcAft>
-            </a:pPr>
-            <a:r>
-              <a:rPr sz="1000" b="1">
-                <a:solidFill>
-                  <a:srgbClr val="B91C1C"/>
-                </a:solidFill>
-                <a:latin typeface="Calibri"/>
-              </a:rPr>
-              <a:t>PK</a:t>
-            </a:r>
-          </a:p>
-        </p:txBody>
-      </p:sp>
-      <p:sp>
-        <p:nvSpPr>
-          <p:cNvPr id="93" name="TextBox 92"/>
-          <p:cNvSpPr txBox="1"/>
-          <p:nvPr/>
-        </p:nvSpPr>
-        <p:spPr>
-          <a:xfrm>
-            <a:off x="8778240" y="5486399"/>
-            <a:ext cx="2011679" cy="274320"/>
-          </a:xfrm>
-          <a:prstGeom prst="rect">
-            <a:avLst/>
-          </a:prstGeom>
-          <a:noFill/>
-        </p:spPr>
-        <p:txBody>
-          <a:bodyPr wrap="square" anchor="t" lIns="45720" rIns="45720">
-            <a:spAutoFit/>
-          </a:bodyPr>
-          <a:lstStyle/>
-          <a:p>
-            <a:pPr algn="l">
-              <a:spcAft>
-                <a:spcPts val="600"/>
-              </a:spcAft>
-            </a:pPr>
-            <a:r>
-              <a:rPr sz="1200" b="0">
-                <a:solidFill>
-                  <a:srgbClr val="0F172A"/>
-                </a:solidFill>
-                <a:latin typeface="Calibri"/>
-              </a:rPr>
-              <a:t>Moyen de paiement</a:t>
-            </a:r>
-          </a:p>
-        </p:txBody>
-      </p:sp>
-      <p:cxnSp>
-        <p:nvCxnSpPr>
-          <p:cNvPr id="94" name="Connector 93"/>
-          <p:cNvCxnSpPr/>
-          <p:nvPr/>
-        </p:nvCxnSpPr>
-        <p:spPr>
-          <a:xfrm>
-            <a:off x="7863840" y="3538727"/>
-            <a:ext cx="822960" cy="1810513"/>
-          </a:xfrm>
-          <a:prstGeom prst="line">
-            <a:avLst/>
-          </a:prstGeom>
-          <a:ln w="19050">
-            <a:solidFill>
-              <a:srgbClr val="475569"/>
-            </a:solidFill>
-          </a:ln>
-        </p:spPr>
-        <p:style>
-          <a:lnRef idx="2">
-            <a:schemeClr val="accent1"/>
-          </a:lnRef>
-          <a:fillRef idx="0">
-            <a:schemeClr val="accent1"/>
-          </a:fillRef>
-          <a:effectRef idx="1">
-            <a:schemeClr val="accent1"/>
-          </a:effectRef>
-          <a:fontRef idx="minor">
-            <a:schemeClr val="tx1"/>
-          </a:fontRef>
-        </p:style>
-      </p:cxnSp>
-      <p:sp>
-        <p:nvSpPr>
-          <p:cNvPr id="95" name="TextBox 94"/>
-          <p:cNvSpPr txBox="1"/>
-          <p:nvPr/>
-        </p:nvSpPr>
-        <p:spPr>
-          <a:xfrm>
-            <a:off x="8412480" y="5074920"/>
-            <a:ext cx="274320" cy="274320"/>
-          </a:xfrm>
-          <a:prstGeom prst="rect">
-            <a:avLst/>
-          </a:prstGeom>
-          <a:noFill/>
-        </p:spPr>
-        <p:txBody>
-          <a:bodyPr wrap="square" anchor="t" lIns="45720" rIns="45720">
-            <a:spAutoFit/>
-          </a:bodyPr>
-          <a:lstStyle/>
-          <a:p>
-            <a:pPr algn="l">
-              <a:spcAft>
-                <a:spcPts val="600"/>
-              </a:spcAft>
-            </a:pPr>
-            <a:r>
-              <a:rPr sz="1100" b="1">
-                <a:solidFill>
-                  <a:srgbClr val="475569"/>
-                </a:solidFill>
-                <a:latin typeface="Calibri"/>
-              </a:rPr>
-              <a:t>1</a:t>
-            </a:r>
-          </a:p>
-        </p:txBody>
-      </p:sp>
-      <p:sp>
-        <p:nvSpPr>
-          <p:cNvPr id="96" name="TextBox 95"/>
-          <p:cNvSpPr txBox="1"/>
-          <p:nvPr/>
-        </p:nvSpPr>
-        <p:spPr>
-          <a:xfrm>
-            <a:off x="7891271" y="3264408"/>
-            <a:ext cx="274320" cy="274320"/>
-          </a:xfrm>
-          <a:prstGeom prst="rect">
-            <a:avLst/>
-          </a:prstGeom>
-          <a:noFill/>
-        </p:spPr>
-        <p:txBody>
-          <a:bodyPr wrap="square" anchor="t" lIns="45720" rIns="45720">
-            <a:spAutoFit/>
-          </a:bodyPr>
-          <a:lstStyle/>
-          <a:p>
-            <a:pPr algn="l">
-              <a:spcAft>
-                <a:spcPts val="600"/>
-              </a:spcAft>
-            </a:pPr>
-            <a:r>
-              <a:rPr sz="1100" b="1">
-                <a:solidFill>
-                  <a:srgbClr val="475569"/>
-                </a:solidFill>
-                <a:latin typeface="Calibri"/>
-              </a:rPr>
-              <a:t>N</a:t>
-            </a:r>
-          </a:p>
-        </p:txBody>
-      </p:sp>
-      <p:sp>
-        <p:nvSpPr>
-          <p:cNvPr id="97" name="TextBox 96"/>
+          <p:cNvPr id="62" name="TextBox 61"/>
           <p:cNvSpPr txBox="1"/>
           <p:nvPr/>
         </p:nvSpPr>
@@ -13641,7 +12502,7 @@
                 </a:solidFill>
                 <a:latin typeface="Calibri"/>
               </a:rPr>
-              <a:t>Six tables de faits et leurs mesures</a:t>
+              <a:t>Trois tables de faits et leurs mesures</a:t>
             </a:r>
           </a:p>
         </p:txBody>
@@ -13734,7 +12595,7 @@
         </p:nvGraphicFramePr>
         <p:xfrm>
           <a:off x="502920" y="1325880"/>
-          <a:ext cx="11201400" cy="4480559"/>
+          <a:ext cx="11201400" cy="4343400"/>
         </p:xfrm>
         <a:graphic>
           <a:graphicData uri="http://schemas.openxmlformats.org/drawingml/2006/table">
@@ -13749,7 +12610,7 @@
                 <a:gridCol w="3108960"/>
                 <a:gridCol w="2240280"/>
               </a:tblGrid>
-              <a:tr h="640079">
+              <a:tr h="868680">
                 <a:tc>
                   <a:txBody>
                     <a:bodyPr wrap="square"/>
@@ -13861,7 +12722,7 @@
                   </a:tcPr>
                 </a:tc>
               </a:tr>
-              <a:tr h="640079">
+              <a:tr h="868680">
                 <a:tc>
                   <a:txBody>
                     <a:bodyPr wrap="square"/>
@@ -13918,7 +12779,7 @@
                           </a:solidFill>
                           <a:latin typeface="Calibri"/>
                         </a:rPr>
-                        <a:t>25 743</a:t>
+                        <a:t>91 995</a:t>
                       </a:r>
                     </a:p>
                   </a:txBody>
@@ -13940,7 +12801,18 @@
                           </a:solidFill>
                           <a:latin typeface="Calibri"/>
                         </a:rPr>
-                        <a:t>QuantiteVendue, CA_HT, CA_TTC, Remise_HT, Cout_HT, Marge_HT</a:t>
+                        <a:t>QuantiteVendue, Remise_HT, CA_HT, Cout_HT</a:t>
+                      </a:r>
+                    </a:p>
+                    <a:p>
+                      <a:r>
+                        <a:rPr sz="1200" b="0">
+                          <a:solidFill>
+                            <a:srgbClr val="0F172A"/>
+                          </a:solidFill>
+                          <a:latin typeface="Calibri"/>
+                        </a:rPr>
+                        <a:t>(+ Document_Id pour compter les ventes)</a:t>
                       </a:r>
                     </a:p>
                   </a:txBody>
@@ -13962,7 +12834,7 @@
                           </a:solidFill>
                           <a:latin typeface="Calibri"/>
                         </a:rPr>
-                        <a:t>Temps, Produit, Client, Paiement, Document, Utilisateur</a:t>
+                        <a:t>Temps, Produit, Client</a:t>
                       </a:r>
                     </a:p>
                   </a:txBody>
@@ -13973,7 +12845,7 @@
                   </a:tcPr>
                 </a:tc>
               </a:tr>
-              <a:tr h="640079">
+              <a:tr h="868680">
                 <a:tc>
                   <a:txBody>
                     <a:bodyPr wrap="square"/>
@@ -13986,7 +12858,7 @@
                           </a:solidFill>
                           <a:latin typeface="Calibri"/>
                         </a:rPr>
-                        <a:t>fait_achats</a:t>
+                        <a:t>fait_stock_actuel</a:t>
                       </a:r>
                     </a:p>
                   </a:txBody>
@@ -14008,7 +12880,7 @@
                           </a:solidFill>
                           <a:latin typeface="Calibri"/>
                         </a:rPr>
-                        <a:t>1 produit acheté sur 1 document fournisseur</a:t>
+                        <a:t>1 produit à la date de snapshot (29/09/2026)</a:t>
                       </a:r>
                     </a:p>
                   </a:txBody>
@@ -14030,7 +12902,7 @@
                           </a:solidFill>
                           <a:latin typeface="Calibri"/>
                         </a:rPr>
-                        <a:t>6 980</a:t>
+                        <a:t>6 842</a:t>
                       </a:r>
                     </a:p>
                   </a:txBody>
@@ -14052,7 +12924,7 @@
                           </a:solidFill>
                           <a:latin typeface="Calibri"/>
                         </a:rPr>
-                        <a:t>QuantiteAchetee, MontantAchat_HT, MontantAchat_TTC</a:t>
+                        <a:t>Quantity</a:t>
                       </a:r>
                     </a:p>
                   </a:txBody>
@@ -14074,7 +12946,7 @@
                           </a:solidFill>
                           <a:latin typeface="Calibri"/>
                         </a:rPr>
-                        <a:t>Temps, Produit, Fournisseur, Document</a:t>
+                        <a:t>Temps, Produit</a:t>
                       </a:r>
                     </a:p>
                   </a:txBody>
@@ -14085,7 +12957,7 @@
                   </a:tcPr>
                 </a:tc>
               </a:tr>
-              <a:tr h="640079">
+              <a:tr h="868680">
                 <a:tc>
                   <a:txBody>
                     <a:bodyPr wrap="square"/>
@@ -14142,7 +13014,7 @@
                           </a:solidFill>
                           <a:latin typeface="Calibri"/>
                         </a:rPr>
-                        <a:t>10 899</a:t>
+                        <a:t>40 160</a:t>
                       </a:r>
                     </a:p>
                   </a:txBody>
@@ -14164,7 +13036,18 @@
                           </a:solidFill>
                           <a:latin typeface="Calibri"/>
                         </a:rPr>
-                        <a:t>Amount, UsedAmount</a:t>
+                        <a:t>Amount</a:t>
+                      </a:r>
+                    </a:p>
+                    <a:p>
+                      <a:r>
+                        <a:rPr sz="1200" b="0">
+                          <a:solidFill>
+                            <a:srgbClr val="0F172A"/>
+                          </a:solidFill>
+                          <a:latin typeface="Calibri"/>
+                        </a:rPr>
+                        <a:t>(+ EstPaiementFournisseur pour filtrer)</a:t>
                       </a:r>
                     </a:p>
                   </a:txBody>
@@ -14186,7 +13069,7 @@
                           </a:solidFill>
                           <a:latin typeface="Calibri"/>
                         </a:rPr>
-                        <a:t>Temps, Paiement, Client, Fournisseur, Document</a:t>
+                        <a:t>Temps, Paiement</a:t>
                       </a:r>
                     </a:p>
                   </a:txBody>
@@ -14197,7 +13080,7 @@
                   </a:tcPr>
                 </a:tc>
               </a:tr>
-              <a:tr h="640079">
+              <a:tr h="868680">
                 <a:tc>
                   <a:txBody>
                     <a:bodyPr wrap="square"/>
@@ -14210,7 +13093,7 @@
                           </a:solidFill>
                           <a:latin typeface="Calibri"/>
                         </a:rPr>
-                        <a:t>fait_stock_mouvements</a:t>
+                        <a:t>Mesures Power BI</a:t>
                       </a:r>
                     </a:p>
                   </a:txBody>
@@ -14232,7 +13115,7 @@
                           </a:solidFill>
                           <a:latin typeface="Calibri"/>
                         </a:rPr>
-                        <a:t>1 mouvement de stock</a:t>
+                        <a:t>calculées, non stockées</a:t>
                       </a:r>
                     </a:p>
                   </a:txBody>
@@ -14254,7 +13137,7 @@
                           </a:solidFill>
                           <a:latin typeface="Calibri"/>
                         </a:rPr>
-                        <a:t>49 609</a:t>
+                        <a:t>—</a:t>
                       </a:r>
                     </a:p>
                   </a:txBody>
@@ -14276,7 +13159,18 @@
                           </a:solidFill>
                           <a:latin typeface="Calibri"/>
                         </a:rPr>
-                        <a:t>Quantity, CurrentBalance, ValeurMouvement_HT</a:t>
+                        <a:t>Marge HT, panier moyen, croissance, clients actifs,</a:t>
+                      </a:r>
+                    </a:p>
+                    <a:p>
+                      <a:r>
+                        <a:rPr sz="1200" b="0">
+                          <a:solidFill>
+                            <a:srgbClr val="0F172A"/>
+                          </a:solidFill>
+                          <a:latin typeface="Calibri"/>
+                        </a:rPr>
+                        <a:t>ruptures, stock faible, montant encaissé</a:t>
                       </a:r>
                     </a:p>
                   </a:txBody>
@@ -14298,231 +13192,7 @@
                           </a:solidFill>
                           <a:latin typeface="Calibri"/>
                         </a:rPr>
-                        <a:t>Temps, Produit, Document, Utilisateur</a:t>
-                      </a:r>
-                    </a:p>
-                  </a:txBody>
-                  <a:tcPr marL="64008" marR="64008" marT="36576" marB="36576" anchor="ctr">
-                    <a:solidFill>
-                      <a:srgbClr val="F8FAFC"/>
-                    </a:solidFill>
-                  </a:tcPr>
-                </a:tc>
-              </a:tr>
-              <a:tr h="640079">
-                <a:tc>
-                  <a:txBody>
-                    <a:bodyPr wrap="square"/>
-                    <a:lstStyle/>
-                    <a:p>
-                      <a:r>
-                        <a:rPr sz="1200" b="1">
-                          <a:solidFill>
-                            <a:srgbClr val="0F172A"/>
-                          </a:solidFill>
-                          <a:latin typeface="Calibri"/>
-                        </a:rPr>
-                        <a:t>fait_stock_hebdo</a:t>
-                      </a:r>
-                    </a:p>
-                  </a:txBody>
-                  <a:tcPr marL="64008" marR="64008" marT="36576" marB="36576" anchor="ctr">
-                    <a:solidFill>
-                      <a:srgbClr val="FFFFFF"/>
-                    </a:solidFill>
-                  </a:tcPr>
-                </a:tc>
-                <a:tc>
-                  <a:txBody>
-                    <a:bodyPr wrap="square"/>
-                    <a:lstStyle/>
-                    <a:p>
-                      <a:r>
-                        <a:rPr sz="1200" b="0">
-                          <a:solidFill>
-                            <a:srgbClr val="0F172A"/>
-                          </a:solidFill>
-                          <a:latin typeface="Calibri"/>
-                        </a:rPr>
-                        <a:t>1 produit × 1 semaine</a:t>
-                      </a:r>
-                    </a:p>
-                  </a:txBody>
-                  <a:tcPr marL="64008" marR="64008" marT="36576" marB="36576" anchor="ctr">
-                    <a:solidFill>
-                      <a:srgbClr val="FFFFFF"/>
-                    </a:solidFill>
-                  </a:tcPr>
-                </a:tc>
-                <a:tc>
-                  <a:txBody>
-                    <a:bodyPr wrap="square"/>
-                    <a:lstStyle/>
-                    <a:p>
-                      <a:r>
-                        <a:rPr sz="1200" b="0">
-                          <a:solidFill>
-                            <a:srgbClr val="0F172A"/>
-                          </a:solidFill>
-                          <a:latin typeface="Calibri"/>
-                        </a:rPr>
-                        <a:t>190 626</a:t>
-                      </a:r>
-                    </a:p>
-                  </a:txBody>
-                  <a:tcPr marL="64008" marR="64008" marT="36576" marB="36576" anchor="ctr">
-                    <a:solidFill>
-                      <a:srgbClr val="FFFFFF"/>
-                    </a:solidFill>
-                  </a:tcPr>
-                </a:tc>
-                <a:tc>
-                  <a:txBody>
-                    <a:bodyPr wrap="square"/>
-                    <a:lstStyle/>
-                    <a:p>
-                      <a:r>
-                        <a:rPr sz="1200" b="0">
-                          <a:solidFill>
-                            <a:srgbClr val="0F172A"/>
-                          </a:solidFill>
-                          <a:latin typeface="Calibri"/>
-                        </a:rPr>
-                        <a:t>StockFinSemaine, QteEntree, QteSortie, QteVendue, CA_HT</a:t>
-                      </a:r>
-                    </a:p>
-                  </a:txBody>
-                  <a:tcPr marL="64008" marR="64008" marT="36576" marB="36576" anchor="ctr">
-                    <a:solidFill>
-                      <a:srgbClr val="FFFFFF"/>
-                    </a:solidFill>
-                  </a:tcPr>
-                </a:tc>
-                <a:tc>
-                  <a:txBody>
-                    <a:bodyPr wrap="square"/>
-                    <a:lstStyle/>
-                    <a:p>
-                      <a:r>
-                        <a:rPr sz="1200" b="0">
-                          <a:solidFill>
-                            <a:srgbClr val="0F172A"/>
-                          </a:solidFill>
-                          <a:latin typeface="Calibri"/>
-                        </a:rPr>
-                        <a:t>Temps, Produit</a:t>
-                      </a:r>
-                    </a:p>
-                  </a:txBody>
-                  <a:tcPr marL="64008" marR="64008" marT="36576" marB="36576" anchor="ctr">
-                    <a:solidFill>
-                      <a:srgbClr val="FFFFFF"/>
-                    </a:solidFill>
-                  </a:tcPr>
-                </a:tc>
-              </a:tr>
-              <a:tr h="640085">
-                <a:tc>
-                  <a:txBody>
-                    <a:bodyPr wrap="square"/>
-                    <a:lstStyle/>
-                    <a:p>
-                      <a:r>
-                        <a:rPr sz="1200" b="1">
-                          <a:solidFill>
-                            <a:srgbClr val="0F172A"/>
-                          </a:solidFill>
-                          <a:latin typeface="Calibri"/>
-                        </a:rPr>
-                        <a:t>fait_stock_actuel</a:t>
-                      </a:r>
-                    </a:p>
-                  </a:txBody>
-                  <a:tcPr marL="64008" marR="64008" marT="36576" marB="36576" anchor="ctr">
-                    <a:solidFill>
-                      <a:srgbClr val="F8FAFC"/>
-                    </a:solidFill>
-                  </a:tcPr>
-                </a:tc>
-                <a:tc>
-                  <a:txBody>
-                    <a:bodyPr wrap="square"/>
-                    <a:lstStyle/>
-                    <a:p>
-                      <a:r>
-                        <a:rPr sz="1200" b="0">
-                          <a:solidFill>
-                            <a:srgbClr val="0F172A"/>
-                          </a:solidFill>
-                          <a:latin typeface="Calibri"/>
-                        </a:rPr>
-                        <a:t>1 produit (photo au 30/04/2025)</a:t>
-                      </a:r>
-                    </a:p>
-                  </a:txBody>
-                  <a:tcPr marL="64008" marR="64008" marT="36576" marB="36576" anchor="ctr">
-                    <a:solidFill>
-                      <a:srgbClr val="F8FAFC"/>
-                    </a:solidFill>
-                  </a:tcPr>
-                </a:tc>
-                <a:tc>
-                  <a:txBody>
-                    <a:bodyPr wrap="square"/>
-                    <a:lstStyle/>
-                    <a:p>
-                      <a:r>
-                        <a:rPr sz="1200" b="0">
-                          <a:solidFill>
-                            <a:srgbClr val="0F172A"/>
-                          </a:solidFill>
-                          <a:latin typeface="Calibri"/>
-                        </a:rPr>
-                        <a:t>6 842</a:t>
-                      </a:r>
-                    </a:p>
-                  </a:txBody>
-                  <a:tcPr marL="64008" marR="64008" marT="36576" marB="36576" anchor="ctr">
-                    <a:solidFill>
-                      <a:srgbClr val="F8FAFC"/>
-                    </a:solidFill>
-                  </a:tcPr>
-                </a:tc>
-                <a:tc>
-                  <a:txBody>
-                    <a:bodyPr wrap="square"/>
-                    <a:lstStyle/>
-                    <a:p>
-                      <a:r>
-                        <a:rPr sz="1200" b="0">
-                          <a:solidFill>
-                            <a:srgbClr val="0F172A"/>
-                          </a:solidFill>
-                          <a:latin typeface="Calibri"/>
-                        </a:rPr>
-                        <a:t>Quantity, QteVendue_Periode, Rotation, ValeurStock_HT</a:t>
-                      </a:r>
-                    </a:p>
-                  </a:txBody>
-                  <a:tcPr marL="64008" marR="64008" marT="36576" marB="36576" anchor="ctr">
-                    <a:solidFill>
-                      <a:srgbClr val="F8FAFC"/>
-                    </a:solidFill>
-                  </a:tcPr>
-                </a:tc>
-                <a:tc>
-                  <a:txBody>
-                    <a:bodyPr wrap="square"/>
-                    <a:lstStyle/>
-                    <a:p>
-                      <a:r>
-                        <a:rPr sz="1200" b="0">
-                          <a:solidFill>
-                            <a:srgbClr val="0F172A"/>
-                          </a:solidFill>
-                          <a:latin typeface="Calibri"/>
-                        </a:rPr>
-                        <a:t>Temps, Produit</a:t>
+                        <a:t>selon la mesure</a:t>
                       </a:r>
                     </a:p>
                   </a:txBody>
@@ -14670,7 +13340,7 @@
                 </a:solidFill>
                 <a:latin typeface="Calibri"/>
               </a:rPr>
-              <a:t>Huit dimensions conformes, partagées par les faits</a:t>
+              <a:t>Quatre dimensions conformes, partagées par les faits</a:t>
             </a:r>
           </a:p>
         </p:txBody>
@@ -14763,7 +13433,7 @@
         </p:nvGraphicFramePr>
         <p:xfrm>
           <a:off x="502920" y="1325880"/>
-          <a:ext cx="11201400" cy="4279392"/>
+          <a:ext cx="11201400" cy="3429000"/>
         </p:xfrm>
         <a:graphic>
           <a:graphicData uri="http://schemas.openxmlformats.org/drawingml/2006/table">
@@ -14777,14 +13447,14 @@
                 <a:gridCol w="6172200"/>
                 <a:gridCol w="1097280"/>
               </a:tblGrid>
-              <a:tr h="475488">
+              <a:tr h="685800">
                 <a:tc>
                   <a:txBody>
                     <a:bodyPr wrap="square"/>
                     <a:lstStyle/>
                     <a:p>
                       <a:r>
-                        <a:rPr sz="1250" b="1">
+                        <a:rPr sz="1300" b="1">
                           <a:solidFill>
                             <a:srgbClr val="FFFFFF"/>
                           </a:solidFill>
@@ -14806,7 +13476,7 @@
                     <a:lstStyle/>
                     <a:p>
                       <a:r>
-                        <a:rPr sz="1250" b="1">
+                        <a:rPr sz="1300" b="1">
                           <a:solidFill>
                             <a:srgbClr val="FFFFFF"/>
                           </a:solidFill>
@@ -14828,7 +13498,7 @@
                     <a:lstStyle/>
                     <a:p>
                       <a:r>
-                        <a:rPr sz="1250" b="1">
+                        <a:rPr sz="1300" b="1">
                           <a:solidFill>
                             <a:srgbClr val="FFFFFF"/>
                           </a:solidFill>
@@ -14850,7 +13520,7 @@
                     <a:lstStyle/>
                     <a:p>
                       <a:r>
-                        <a:rPr sz="1250" b="1">
+                        <a:rPr sz="1300" b="1">
                           <a:solidFill>
                             <a:srgbClr val="FFFFFF"/>
                           </a:solidFill>
@@ -14867,14 +13537,14 @@
                   </a:tcPr>
                 </a:tc>
               </a:tr>
-              <a:tr h="475488">
+              <a:tr h="685800">
                 <a:tc>
                   <a:txBody>
                     <a:bodyPr wrap="square"/>
                     <a:lstStyle/>
                     <a:p>
                       <a:r>
-                        <a:rPr sz="1250" b="1">
+                        <a:rPr sz="1300" b="1">
                           <a:solidFill>
                             <a:srgbClr val="0F172A"/>
                           </a:solidFill>
@@ -14896,7 +13566,7 @@
                     <a:lstStyle/>
                     <a:p>
                       <a:r>
-                        <a:rPr sz="1250" b="0">
+                        <a:rPr sz="1300" b="0">
                           <a:solidFill>
                             <a:srgbClr val="0F172A"/>
                           </a:solidFill>
@@ -14918,13 +13588,13 @@
                     <a:lstStyle/>
                     <a:p>
                       <a:r>
-                        <a:rPr sz="1250" b="0">
+                        <a:rPr sz="1300" b="0">
                           <a:solidFill>
                             <a:srgbClr val="0F172A"/>
                           </a:solidFill>
                           <a:latin typeface="Calibri"/>
                         </a:rPr>
-                        <a:t>Jour, semaine, mois, saison, férié, vacances A/B/C, météo, épidémies (Sentinelles)</a:t>
+                        <a:t>Date, année, trimestre, mois, semaine ISO, jour férié (30/09/2024 → 29/09/2026)</a:t>
                       </a:r>
                     </a:p>
                   </a:txBody>
@@ -14940,13 +13610,13 @@
                     <a:lstStyle/>
                     <a:p>
                       <a:r>
-                        <a:rPr sz="1250" b="0">
+                        <a:rPr sz="1300" b="0">
                           <a:solidFill>
                             <a:srgbClr val="0F172A"/>
                           </a:solidFill>
                           <a:latin typeface="Calibri"/>
                         </a:rPr>
-                        <a:t>487</a:t>
+                        <a:t>730</a:t>
                       </a:r>
                     </a:p>
                   </a:txBody>
@@ -14957,14 +13627,14 @@
                   </a:tcPr>
                 </a:tc>
               </a:tr>
-              <a:tr h="475488">
+              <a:tr h="685800">
                 <a:tc>
                   <a:txBody>
                     <a:bodyPr wrap="square"/>
                     <a:lstStyle/>
                     <a:p>
                       <a:r>
-                        <a:rPr sz="1250" b="1">
+                        <a:rPr sz="1300" b="1">
                           <a:solidFill>
                             <a:srgbClr val="0F172A"/>
                           </a:solidFill>
@@ -14986,7 +13656,7 @@
                     <a:lstStyle/>
                     <a:p>
                       <a:r>
-                        <a:rPr sz="1250" b="0">
+                        <a:rPr sz="1300" b="0">
                           <a:solidFill>
                             <a:srgbClr val="0F172A"/>
                           </a:solidFill>
@@ -15008,13 +13678,13 @@
                     <a:lstStyle/>
                     <a:p>
                       <a:r>
-                        <a:rPr sz="1250" b="0">
+                        <a:rPr sz="1300" b="0">
                           <a:solidFill>
                             <a:srgbClr val="0F172A"/>
                           </a:solidFill>
                           <a:latin typeface="Calibri"/>
                         </a:rPr>
-                        <a:t>Libellé, famille, marque, code-barres, prix d'achat / vente, TVA, seuil d'alerte</a:t>
+                        <a:t>Libellé, famille, marque, seuil d'alerte de stock</a:t>
                       </a:r>
                     </a:p>
                   </a:txBody>
@@ -15030,7 +13700,7 @@
                     <a:lstStyle/>
                     <a:p>
                       <a:r>
-                        <a:rPr sz="1250" b="0">
+                        <a:rPr sz="1300" b="0">
                           <a:solidFill>
                             <a:srgbClr val="0F172A"/>
                           </a:solidFill>
@@ -15047,14 +13717,14 @@
                   </a:tcPr>
                 </a:tc>
               </a:tr>
-              <a:tr h="475488">
+              <a:tr h="685800">
                 <a:tc>
                   <a:txBody>
                     <a:bodyPr wrap="square"/>
                     <a:lstStyle/>
                     <a:p>
                       <a:r>
-                        <a:rPr sz="1250" b="1">
+                        <a:rPr sz="1300" b="1">
                           <a:solidFill>
                             <a:srgbClr val="0F172A"/>
                           </a:solidFill>
@@ -15076,7 +13746,7 @@
                     <a:lstStyle/>
                     <a:p>
                       <a:r>
-                        <a:rPr sz="1250" b="0">
+                        <a:rPr sz="1300" b="0">
                           <a:solidFill>
                             <a:srgbClr val="0F172A"/>
                           </a:solidFill>
@@ -15098,13 +13768,13 @@
                     <a:lstStyle/>
                     <a:p>
                       <a:r>
-                        <a:rPr sz="1250" b="0">
+                        <a:rPr sz="1300" b="0">
                           <a:solidFill>
                             <a:srgbClr val="0F172A"/>
                           </a:solidFill>
                           <a:latin typeface="Calibri"/>
                         </a:rPr>
-                        <a:t>Nom, type (particulier / B2B / comptoir anonyme), ville, solde</a:t>
+                        <a:t>Nom, type (particulier / B2B / comptoir anonyme), client identifié</a:t>
                       </a:r>
                     </a:p>
                   </a:txBody>
@@ -15120,7 +13790,7 @@
                     <a:lstStyle/>
                     <a:p>
                       <a:r>
-                        <a:rPr sz="1250" b="0">
+                        <a:rPr sz="1300" b="0">
                           <a:solidFill>
                             <a:srgbClr val="0F172A"/>
                           </a:solidFill>
@@ -15137,194 +13807,14 @@
                   </a:tcPr>
                 </a:tc>
               </a:tr>
-              <a:tr h="475488">
+              <a:tr h="685800">
                 <a:tc>
                   <a:txBody>
                     <a:bodyPr wrap="square"/>
                     <a:lstStyle/>
                     <a:p>
                       <a:r>
-                        <a:rPr sz="1250" b="1">
-                          <a:solidFill>
-                            <a:srgbClr val="0F172A"/>
-                          </a:solidFill>
-                          <a:latin typeface="Calibri"/>
-                        </a:rPr>
-                        <a:t>dim_fournisseur</a:t>
-                      </a:r>
-                    </a:p>
-                  </a:txBody>
-                  <a:tcPr marL="64008" marR="64008" marT="36576" marB="36576" anchor="ctr">
-                    <a:solidFill>
-                      <a:srgbClr val="F8FAFC"/>
-                    </a:solidFill>
-                  </a:tcPr>
-                </a:tc>
-                <a:tc>
-                  <a:txBody>
-                    <a:bodyPr wrap="square"/>
-                    <a:lstStyle/>
-                    <a:p>
-                      <a:r>
-                        <a:rPr sz="1250" b="0">
-                          <a:solidFill>
-                            <a:srgbClr val="0F172A"/>
-                          </a:solidFill>
-                          <a:latin typeface="Calibri"/>
-                        </a:rPr>
-                        <a:t>Company_Id</a:t>
-                      </a:r>
-                    </a:p>
-                  </a:txBody>
-                  <a:tcPr marL="64008" marR="64008" marT="36576" marB="36576" anchor="ctr">
-                    <a:solidFill>
-                      <a:srgbClr val="F8FAFC"/>
-                    </a:solidFill>
-                  </a:tcPr>
-                </a:tc>
-                <a:tc>
-                  <a:txBody>
-                    <a:bodyPr wrap="square"/>
-                    <a:lstStyle/>
-                    <a:p>
-                      <a:r>
-                        <a:rPr sz="1250" b="0">
-                          <a:solidFill>
-                            <a:srgbClr val="0F172A"/>
-                          </a:solidFill>
-                          <a:latin typeface="Calibri"/>
-                        </a:rPr>
-                        <a:t>Nom, ville, solde</a:t>
-                      </a:r>
-                    </a:p>
-                  </a:txBody>
-                  <a:tcPr marL="64008" marR="64008" marT="36576" marB="36576" anchor="ctr">
-                    <a:solidFill>
-                      <a:srgbClr val="F8FAFC"/>
-                    </a:solidFill>
-                  </a:tcPr>
-                </a:tc>
-                <a:tc>
-                  <a:txBody>
-                    <a:bodyPr wrap="square"/>
-                    <a:lstStyle/>
-                    <a:p>
-                      <a:r>
-                        <a:rPr sz="1250" b="0">
-                          <a:solidFill>
-                            <a:srgbClr val="0F172A"/>
-                          </a:solidFill>
-                          <a:latin typeface="Calibri"/>
-                        </a:rPr>
-                        <a:t>116</a:t>
-                      </a:r>
-                    </a:p>
-                  </a:txBody>
-                  <a:tcPr marL="64008" marR="64008" marT="36576" marB="36576" anchor="ctr">
-                    <a:solidFill>
-                      <a:srgbClr val="F8FAFC"/>
-                    </a:solidFill>
-                  </a:tcPr>
-                </a:tc>
-              </a:tr>
-              <a:tr h="475488">
-                <a:tc>
-                  <a:txBody>
-                    <a:bodyPr wrap="square"/>
-                    <a:lstStyle/>
-                    <a:p>
-                      <a:r>
-                        <a:rPr sz="1250" b="1">
-                          <a:solidFill>
-                            <a:srgbClr val="0F172A"/>
-                          </a:solidFill>
-                          <a:latin typeface="Calibri"/>
-                        </a:rPr>
-                        <a:t>dim_document</a:t>
-                      </a:r>
-                    </a:p>
-                  </a:txBody>
-                  <a:tcPr marL="64008" marR="64008" marT="36576" marB="36576" anchor="ctr">
-                    <a:solidFill>
-                      <a:srgbClr val="FFFFFF"/>
-                    </a:solidFill>
-                  </a:tcPr>
-                </a:tc>
-                <a:tc>
-                  <a:txBody>
-                    <a:bodyPr wrap="square"/>
-                    <a:lstStyle/>
-                    <a:p>
-                      <a:r>
-                        <a:rPr sz="1250" b="0">
-                          <a:solidFill>
-                            <a:srgbClr val="0F172A"/>
-                          </a:solidFill>
-                          <a:latin typeface="Calibri"/>
-                        </a:rPr>
-                        <a:t>Document_Id</a:t>
-                      </a:r>
-                    </a:p>
-                  </a:txBody>
-                  <a:tcPr marL="64008" marR="64008" marT="36576" marB="36576" anchor="ctr">
-                    <a:solidFill>
-                      <a:srgbClr val="FFFFFF"/>
-                    </a:solidFill>
-                  </a:tcPr>
-                </a:tc>
-                <a:tc>
-                  <a:txBody>
-                    <a:bodyPr wrap="square"/>
-                    <a:lstStyle/>
-                    <a:p>
-                      <a:r>
-                        <a:rPr sz="1250" b="0">
-                          <a:solidFill>
-                            <a:srgbClr val="0F172A"/>
-                          </a:solidFill>
-                          <a:latin typeface="Calibri"/>
-                        </a:rPr>
-                        <a:t>Numéro, type, statut, canal (comptoir / facture / achat)</a:t>
-                      </a:r>
-                    </a:p>
-                  </a:txBody>
-                  <a:tcPr marL="64008" marR="64008" marT="36576" marB="36576" anchor="ctr">
-                    <a:solidFill>
-                      <a:srgbClr val="FFFFFF"/>
-                    </a:solidFill>
-                  </a:tcPr>
-                </a:tc>
-                <a:tc>
-                  <a:txBody>
-                    <a:bodyPr wrap="square"/>
-                    <a:lstStyle/>
-                    <a:p>
-                      <a:r>
-                        <a:rPr sz="1250" b="0">
-                          <a:solidFill>
-                            <a:srgbClr val="0F172A"/>
-                          </a:solidFill>
-                          <a:latin typeface="Calibri"/>
-                        </a:rPr>
-                        <a:t>12 543</a:t>
-                      </a:r>
-                    </a:p>
-                  </a:txBody>
-                  <a:tcPr marL="64008" marR="64008" marT="36576" marB="36576" anchor="ctr">
-                    <a:solidFill>
-                      <a:srgbClr val="FFFFFF"/>
-                    </a:solidFill>
-                  </a:tcPr>
-                </a:tc>
-              </a:tr>
-              <a:tr h="475488">
-                <a:tc>
-                  <a:txBody>
-                    <a:bodyPr wrap="square"/>
-                    <a:lstStyle/>
-                    <a:p>
-                      <a:r>
-                        <a:rPr sz="1250" b="1">
+                        <a:rPr sz="1300" b="1">
                           <a:solidFill>
                             <a:srgbClr val="0F172A"/>
                           </a:solidFill>
@@ -15346,7 +13836,7 @@
                     <a:lstStyle/>
                     <a:p>
                       <a:r>
-                        <a:rPr sz="1250" b="0">
+                        <a:rPr sz="1300" b="0">
                           <a:solidFill>
                             <a:srgbClr val="0F172A"/>
                           </a:solidFill>
@@ -15368,13 +13858,13 @@
                     <a:lstStyle/>
                     <a:p>
                       <a:r>
-                        <a:rPr sz="1250" b="0">
+                        <a:rPr sz="1300" b="0">
                           <a:solidFill>
                             <a:srgbClr val="0F172A"/>
                           </a:solidFill>
                           <a:latin typeface="Calibri"/>
                         </a:rPr>
-                        <a:t>Espèces, carte bancaire, chèque, crédit, jetons</a:t>
+                        <a:t>Espèces, carte bancaire, chèque, crédit, jetons, non renseigné</a:t>
                       </a:r>
                     </a:p>
                   </a:txBody>
@@ -15390,193 +13880,13 @@
                     <a:lstStyle/>
                     <a:p>
                       <a:r>
-                        <a:rPr sz="1250" b="0">
+                        <a:rPr sz="1300" b="0">
                           <a:solidFill>
                             <a:srgbClr val="0F172A"/>
                           </a:solidFill>
                           <a:latin typeface="Calibri"/>
                         </a:rPr>
-                        <a:t>7</a:t>
-                      </a:r>
-                    </a:p>
-                  </a:txBody>
-                  <a:tcPr marL="64008" marR="64008" marT="36576" marB="36576" anchor="ctr">
-                    <a:solidFill>
-                      <a:srgbClr val="F8FAFC"/>
-                    </a:solidFill>
-                  </a:tcPr>
-                </a:tc>
-              </a:tr>
-              <a:tr h="475488">
-                <a:tc>
-                  <a:txBody>
-                    <a:bodyPr wrap="square"/>
-                    <a:lstStyle/>
-                    <a:p>
-                      <a:r>
-                        <a:rPr sz="1250" b="1">
-                          <a:solidFill>
-                            <a:srgbClr val="0F172A"/>
-                          </a:solidFill>
-                          <a:latin typeface="Calibri"/>
-                        </a:rPr>
-                        <a:t>dim_utilisateur</a:t>
-                      </a:r>
-                    </a:p>
-                  </a:txBody>
-                  <a:tcPr marL="64008" marR="64008" marT="36576" marB="36576" anchor="ctr">
-                    <a:solidFill>
-                      <a:srgbClr val="FFFFFF"/>
-                    </a:solidFill>
-                  </a:tcPr>
-                </a:tc>
-                <a:tc>
-                  <a:txBody>
-                    <a:bodyPr wrap="square"/>
-                    <a:lstStyle/>
-                    <a:p>
-                      <a:r>
-                        <a:rPr sz="1250" b="0">
-                          <a:solidFill>
-                            <a:srgbClr val="0F172A"/>
-                          </a:solidFill>
-                          <a:latin typeface="Calibri"/>
-                        </a:rPr>
-                        <a:t>User_Id</a:t>
-                      </a:r>
-                    </a:p>
-                  </a:txBody>
-                  <a:tcPr marL="64008" marR="64008" marT="36576" marB="36576" anchor="ctr">
-                    <a:solidFill>
-                      <a:srgbClr val="FFFFFF"/>
-                    </a:solidFill>
-                  </a:tcPr>
-                </a:tc>
-                <a:tc>
-                  <a:txBody>
-                    <a:bodyPr wrap="square"/>
-                    <a:lstStyle/>
-                    <a:p>
-                      <a:r>
-                        <a:rPr sz="1250" b="0">
-                          <a:solidFill>
-                            <a:srgbClr val="0F172A"/>
-                          </a:solidFill>
-                          <a:latin typeface="Calibri"/>
-                        </a:rPr>
-                        <a:t>Vendeur / caissier</a:t>
-                      </a:r>
-                    </a:p>
-                  </a:txBody>
-                  <a:tcPr marL="64008" marR="64008" marT="36576" marB="36576" anchor="ctr">
-                    <a:solidFill>
-                      <a:srgbClr val="FFFFFF"/>
-                    </a:solidFill>
-                  </a:tcPr>
-                </a:tc>
-                <a:tc>
-                  <a:txBody>
-                    <a:bodyPr wrap="square"/>
-                    <a:lstStyle/>
-                    <a:p>
-                      <a:r>
-                        <a:rPr sz="1250" b="0">
-                          <a:solidFill>
-                            <a:srgbClr val="0F172A"/>
-                          </a:solidFill>
-                          <a:latin typeface="Calibri"/>
-                        </a:rPr>
-                        <a:t>7</a:t>
-                      </a:r>
-                    </a:p>
-                  </a:txBody>
-                  <a:tcPr marL="64008" marR="64008" marT="36576" marB="36576" anchor="ctr">
-                    <a:solidFill>
-                      <a:srgbClr val="FFFFFF"/>
-                    </a:solidFill>
-                  </a:tcPr>
-                </a:tc>
-              </a:tr>
-              <a:tr h="475488">
-                <a:tc>
-                  <a:txBody>
-                    <a:bodyPr wrap="square"/>
-                    <a:lstStyle/>
-                    <a:p>
-                      <a:r>
-                        <a:rPr sz="1250" b="1">
-                          <a:solidFill>
-                            <a:srgbClr val="0F172A"/>
-                          </a:solidFill>
-                          <a:latin typeface="Calibri"/>
-                        </a:rPr>
-                        <a:t>dim_geographie</a:t>
-                      </a:r>
-                    </a:p>
-                  </a:txBody>
-                  <a:tcPr marL="64008" marR="64008" marT="36576" marB="36576" anchor="ctr">
-                    <a:solidFill>
-                      <a:srgbClr val="F8FAFC"/>
-                    </a:solidFill>
-                  </a:tcPr>
-                </a:tc>
-                <a:tc>
-                  <a:txBody>
-                    <a:bodyPr wrap="square"/>
-                    <a:lstStyle/>
-                    <a:p>
-                      <a:r>
-                        <a:rPr sz="1250" b="0">
-                          <a:solidFill>
-                            <a:srgbClr val="0F172A"/>
-                          </a:solidFill>
-                          <a:latin typeface="Calibri"/>
-                        </a:rPr>
-                        <a:t>Geo_Id</a:t>
-                      </a:r>
-                    </a:p>
-                  </a:txBody>
-                  <a:tcPr marL="64008" marR="64008" marT="36576" marB="36576" anchor="ctr">
-                    <a:solidFill>
-                      <a:srgbClr val="F8FAFC"/>
-                    </a:solidFill>
-                  </a:tcPr>
-                </a:tc>
-                <a:tc>
-                  <a:txBody>
-                    <a:bodyPr wrap="square"/>
-                    <a:lstStyle/>
-                    <a:p>
-                      <a:r>
-                        <a:rPr sz="1250" b="0">
-                          <a:solidFill>
-                            <a:srgbClr val="0F172A"/>
-                          </a:solidFill>
-                          <a:latin typeface="Calibri"/>
-                        </a:rPr>
-                        <a:t>Ville, département, région</a:t>
-                      </a:r>
-                    </a:p>
-                  </a:txBody>
-                  <a:tcPr marL="64008" marR="64008" marT="36576" marB="36576" anchor="ctr">
-                    <a:solidFill>
-                      <a:srgbClr val="F8FAFC"/>
-                    </a:solidFill>
-                  </a:tcPr>
-                </a:tc>
-                <a:tc>
-                  <a:txBody>
-                    <a:bodyPr wrap="square"/>
-                    <a:lstStyle/>
-                    <a:p>
-                      <a:r>
-                        <a:rPr sz="1250" b="0">
-                          <a:solidFill>
-                            <a:srgbClr val="0F172A"/>
-                          </a:solidFill>
-                          <a:latin typeface="Calibri"/>
-                        </a:rPr>
-                        <a:t>12</a:t>
+                        <a:t>6</a:t>
                       </a:r>
                     </a:p>
                   </a:txBody>
@@ -15925,7 +14235,7 @@
                 </a:solidFill>
                 <a:latin typeface="Calibri"/>
               </a:rPr>
-              <a:t>Constellation</a:t>
+              <a:t>Constellation réduite</a:t>
             </a:r>
           </a:p>
         </p:txBody>
@@ -15964,7 +14274,7 @@
                 </a:solidFill>
                 <a:latin typeface="Calibri"/>
               </a:rPr>
-              <a:t>Six processus métier (ventes, achats, paiements, stock) partagent les mêmes dimensions : les analyses se croisent naturellement.</a:t>
+              <a:t>Trois processus (ventes, stock, paiements) partagent quatre dimensions : uniquement ce que le cahier demande.</a:t>
             </a:r>
           </a:p>
         </p:txBody>
@@ -16735,7 +15045,7 @@
                 </a:solidFill>
                 <a:latin typeface="Calibri"/>
               </a:rPr>
-              <a:t>Temps enrichi</a:t>
+              <a:t>Stocké ou calculé</a:t>
             </a:r>
           </a:p>
         </p:txBody>
@@ -16774,7 +15084,7 @@
                 </a:solidFill>
                 <a:latin typeface="Calibri"/>
               </a:rPr>
-              <a:t>Calendrier français, météo et épidémies reliés par la date ou la semaine.</a:t>
+              <a:t>Une colonne n'est stockée que si le cahier l'exige et qu'elle ne peut pas être recalculée ; marge, rupture, stock faible sont des mesures.</a:t>
             </a:r>
           </a:p>
         </p:txBody>
@@ -17077,7 +15387,7 @@
                 </a:solidFill>
                 <a:latin typeface="Calibri"/>
               </a:rPr>
-              <a:t>Historique court :</a:t>
+              <a:t>Historique réel court :</a:t>
             </a:r>
             <a:r>
               <a:rPr sz="1500" b="0">
@@ -17086,7 +15396,7 @@
                 </a:solidFill>
                 <a:latin typeface="Calibri"/>
               </a:rPr>
-              <a:t> 7 mois, aucun été observé – une seule occurrence de chaque saison.</a:t>
+              <a:t> 7 mois ; la prolongation à 2 ans est synthétique (hypothèses documentées) – l'apport météo / épidémies se mesure sur le réel.</a:t>
             </a:r>
           </a:p>
           <a:p>
@@ -17179,7 +15489,7 @@
                 </a:solidFill>
                 <a:latin typeface="Calibri"/>
               </a:rPr>
-              <a:t>Chiffres du cahier à revoir :</a:t>
+              <a:t>Moyens de paiement :</a:t>
             </a:r>
             <a:r>
               <a:rPr sz="1500" b="0">
@@ -17188,7 +15498,7 @@
                 </a:solidFill>
                 <a:latin typeface="Calibri"/>
               </a:rPr>
-              <a:t> ventes sous le coût 2,3 % (cahier : 22 %) ; clients identifiés 49 % du CA (cahier : ~60 %).</a:t>
+              <a:t> 92 % des encaissements réels sans moyen renseigné dans la source.</a:t>
             </a:r>
           </a:p>
         </p:txBody>
@@ -17715,7 +16025,7 @@
                 </a:solidFill>
                 <a:latin typeface="Calibri"/>
               </a:rPr>
-              <a:t>Demander l'extension des données à 12 mois</a:t>
+              <a:t>Mesurer l'apport météo / épidémies sur la période réelle</a:t>
             </a:r>
           </a:p>
         </p:txBody>
@@ -19335,6 +17645,40 @@
               <a:t> un export brut de la base du logiciel – 29 fichiers CSV, du 30/09/2024 au 30/04/2025.</a:t>
             </a:r>
           </a:p>
+          <a:p>
+            <a:pPr algn="l">
+              <a:spcAft>
+                <a:spcPts val="1000"/>
+              </a:spcAft>
+            </a:pPr>
+            <a:r>
+              <a:rPr sz="1400">
+                <a:solidFill>
+                  <a:srgbClr val="1E3A8A"/>
+                </a:solidFill>
+                <a:latin typeface="Calibri"/>
+              </a:rPr>
+              <a:t>▪  </a:t>
+            </a:r>
+            <a:r>
+              <a:rPr sz="1600" b="1">
+                <a:solidFill>
+                  <a:srgbClr val="0F172A"/>
+                </a:solidFill>
+                <a:latin typeface="Calibri"/>
+              </a:rPr>
+              <a:t>Prolongation :</a:t>
+            </a:r>
+            <a:r>
+              <a:rPr sz="1600" b="0">
+                <a:solidFill>
+                  <a:srgbClr val="0F172A"/>
+                </a:solidFill>
+                <a:latin typeface="Calibri"/>
+              </a:rPr>
+              <a:t> données synthétiques générées jusqu'au 29/09/2026 (2 ans au total), rangées à part comme donnée externe ; délimitation par la date.</a:t>
+            </a:r>
+          </a:p>
         </p:txBody>
       </p:sp>
       <p:sp>
@@ -19608,7 +17952,7 @@
                 </a:solidFill>
                 <a:latin typeface="Calibri"/>
               </a:rPr>
-              <a:t>sur 7 mois</a:t>
+              <a:t>sur les 7 mois réels</a:t>
             </a:r>
           </a:p>
         </p:txBody>
@@ -19730,7 +18074,7 @@
                 </a:solidFill>
                 <a:latin typeface="Calibri"/>
               </a:rPr>
-              <a:t>ventes (documents)</a:t>
+              <a:t>ventes réelles (documents)</a:t>
             </a:r>
           </a:p>
           <a:p>
@@ -20196,7 +18540,7 @@
                 </a:solidFill>
                 <a:latin typeface="Calibri"/>
               </a:rPr>
-              <a:t>Septembre 2024 exclu : un seul jour d'activité (démarrage du logiciel le 30/09).</a:t>
+              <a:t>Bleu foncé : réel · bleu clair : synthétique. Septembre 2024 exclu (un seul jour d'activité).</a:t>
             </a:r>
           </a:p>
         </p:txBody>
@@ -21612,7 +19956,7 @@
                 </a:solidFill>
                 <a:latin typeface="Calibri"/>
               </a:rPr>
-              <a:t>35 % des produits actifs en rupture</a:t>
+              <a:t>6 % des produits actifs en rupture</a:t>
             </a:r>
           </a:p>
           <a:p>
@@ -22173,7 +20517,7 @@
                           </a:solidFill>
                           <a:latin typeface="Calibri"/>
                         </a:rPr>
-                        <a:t>Quels produits et marques se vendent le plus ? Quel est le panier moyen ?</a:t>
+                        <a:t>Quels produits et marques se vendent le plus et sont les plus rentables ? Quel panier moyen ?</a:t>
                       </a:r>
                     </a:p>
                   </a:txBody>
@@ -22377,7 +20721,7 @@
                           </a:solidFill>
                           <a:latin typeface="Calibri"/>
                         </a:rPr>
-                        <a:t>Quels montants sont encaissés ? Par quel moyen ? Y a-t-il des écarts de caisse ?</a:t>
+                        <a:t>Quel montant est encaissé ? Par quel moyen ? Comment évoluent les encaissements ?</a:t>
                       </a:r>
                     </a:p>
                   </a:txBody>
@@ -23445,7 +21789,7 @@
                 </a:solidFill>
                 <a:latin typeface="Calibri"/>
               </a:rPr>
-              <a:t>Dashboard Stock : ruptures, rotation, ABC</a:t>
+              <a:t>Dashboard Stock : stock disponible, ruptures, stock faible</a:t>
             </a:r>
           </a:p>
         </p:txBody>
@@ -24249,7 +22593,7 @@
                 </a:solidFill>
                 <a:latin typeface="Calibri"/>
               </a:rPr>
-              <a:t>Suivi de la marge, des remises et des ventes sous le coût</a:t>
+              <a:t>Marge HT par produit, famille et marque (dashboard Commercial)</a:t>
             </a:r>
           </a:p>
         </p:txBody>
@@ -25132,7 +23476,7 @@
                           </a:solidFill>
                           <a:latin typeface="Calibri"/>
                         </a:rPr>
-                        <a:t>CA HT/TTC, croissance %, nb de ventes, panier moyen,</a:t>
+                        <a:t>CA HT, croissance %, nb de ventes, panier moyen,</a:t>
                       </a:r>
                     </a:p>
                     <a:p>
@@ -25211,7 +23555,7 @@
                           </a:solidFill>
                           <a:latin typeface="Calibri"/>
                         </a:rPr>
-                        <a:t>Taux de rupture, stock faible, rotation,</a:t>
+                        <a:t>Stock disponible, produits en rupture,</a:t>
                       </a:r>
                     </a:p>
                     <a:p>
@@ -25222,7 +23566,7 @@
                           </a:solidFill>
                           <a:latin typeface="Calibri"/>
                         </a:rPr>
-                        <a:t>couverture en jours, classe ABC</a:t>
+                        <a:t>produits en stock faible</a:t>
                       </a:r>
                     </a:p>
                   </a:txBody>
@@ -25409,7 +23753,7 @@
                           </a:solidFill>
                           <a:latin typeface="Calibri"/>
                         </a:rPr>
-                        <a:t>Marge HT, taux de marge, montant des remises,</a:t>
+                        <a:t>Marge HT = CA HT − coût HT, calculée comme mesure</a:t>
                       </a:r>
                     </a:p>
                     <a:p>
@@ -25420,7 +23764,7 @@
                           </a:solidFill>
                           <a:latin typeface="Calibri"/>
                         </a:rPr>
-                        <a:t>lignes vendues sous le coût</a:t>
+                        <a:t>par produit, famille, marque et période</a:t>
                       </a:r>
                     </a:p>
                   </a:txBody>
@@ -25508,7 +23852,7 @@
                           </a:solidFill>
                           <a:latin typeface="Calibri"/>
                         </a:rPr>
-                        <a:t>Montants encaissés par moyen de paiement,</a:t>
+                        <a:t>Montant encaissé, nombre de paiements,</a:t>
                       </a:r>
                     </a:p>
                     <a:p>
@@ -25519,7 +23863,7 @@
                           </a:solidFill>
                           <a:latin typeface="Calibri"/>
                         </a:rPr>
-                        <a:t>évolution, écarts de caisse</a:t>
+                        <a:t>par moyen de paiement et par période</a:t>
                       </a:r>
                     </a:p>
                   </a:txBody>
@@ -27133,7 +25477,7 @@
                 </a:solidFill>
                 <a:latin typeface="Calibri"/>
               </a:rPr>
-              <a:t>Sources brutes</a:t>
+              <a:t>Sources</a:t>
             </a:r>
           </a:p>
           <a:p>
@@ -27149,7 +25493,7 @@
                 </a:solidFill>
                 <a:latin typeface="Calibri"/>
               </a:rPr>
-              <a:t>29 CSV · export du logiciel</a:t>
+              <a:t>29 CSV réels + données synthétiques</a:t>
             </a:r>
           </a:p>
         </p:txBody>
@@ -27291,7 +25635,7 @@
                 </a:solidFill>
                 <a:latin typeface="Calibri"/>
               </a:rPr>
-              <a:t>30 fichiers · formats unifiés</a:t>
+              <a:t>formats unifiés · réel et synthétique</a:t>
             </a:r>
           </a:p>
         </p:txBody>
@@ -27433,7 +25777,7 @@
                 </a:solidFill>
                 <a:latin typeface="Calibri"/>
               </a:rPr>
-              <a:t>8 dimensions · 6 tables de faits</a:t>
+              <a:t>4 dimensions · 3 tables de faits</a:t>
             </a:r>
           </a:p>
         </p:txBody>
@@ -27790,7 +26134,7 @@
                 </a:solidFill>
                 <a:latin typeface="Calibri"/>
               </a:rPr>
-              <a:t>Données externes ajoutées seulement quand elles répondent à une question : calendrier français, météo (Open-Meteo), épidémies (réseau Sentinelles).</a:t>
+              <a:t>Données externes : météo (Open-Meteo) et épidémies (réseau Sentinelles), réservées à la prévision ML ; calendrier français calculé ; prolongation synthétique à 2 ans.</a:t>
             </a:r>
           </a:p>
         </p:txBody>

</xml_diff>